<commit_message>
wip day 2 data sci class
</commit_message>
<xml_diff>
--- a/lessons/day1/wip/vibe_coding_best_practices.pptx
+++ b/lessons/day1/wip/vibe_coding_best_practices.pptx
@@ -4,6 +4,9 @@
   <p:sldMasterIdLst>
     <p:sldMasterId id="2147483648" r:id="rId1"/>
   </p:sldMasterIdLst>
+  <p:notesMasterIdLst>
+    <p:notesMasterId r:id="rId16"/>
+  </p:notesMasterIdLst>
   <p:sldIdLst>
     <p:sldId id="256" r:id="rId2"/>
     <p:sldId id="257" r:id="rId3"/>
@@ -20,9 +23,6 @@
     <p:sldId id="268" r:id="rId14"/>
     <p:sldId id="269" r:id="rId15"/>
   </p:sldIdLst>
-  <p:notesMasterIdLst>
-    <p:notesMasterId r:id="rId16"/>
-  </p:notesMasterIdLst>
   <p:sldSz cx="12192000" cy="6858000"/>
   <p:notesSz cx="6858000" cy="12192000"/>
   <p:defaultTextStyle>
@@ -117,6 +117,11 @@
       </a:defRPr>
     </a:lvl9pPr>
   </p:defaultTextStyle>
+  <p:extLst>
+    <p:ext uri="{EFAFB233-063F-42B5-8137-9DF3F51BA10A}">
+      <p15:sldGuideLst xmlns:p15="http://schemas.microsoft.com/office/powerpoint/2012/main"/>
+    </p:ext>
+  </p:extLst>
 </p:presentation>
 </file>
 
@@ -142,234 +147,10 @@
           <a:chExt cx="0" cy="0"/>
         </a:xfrm>
       </p:grpSpPr>
-      <p:sp>
-        <p:nvSpPr>
-          <p:cNvPr id="2" name="Header Placeholder 1"/>
-          <p:cNvSpPr>
-            <a:spLocks noGrp="1"/>
-          </p:cNvSpPr>
-          <p:nvPr>
-            <p:ph type="hdr" sz="quarter"/>
-          </p:nvPr>
-        </p:nvSpPr>
-        <p:spPr>
-          <a:xfrm>
-            <a:off x="0" y="0"/>
-            <a:ext cx="2971800" cy="458788"/>
-          </a:xfrm>
-          <a:prstGeom prst="rect">
-            <a:avLst/>
-          </a:prstGeom>
-        </p:spPr>
-        <p:txBody>
-          <a:bodyPr vert="horz" lIns="91440" tIns="45720" rIns="91440" bIns="45720" rtlCol="0"/>
-          <a:lstStyle>
-            <a:lvl1pPr algn="l">
-              <a:defRPr sz="1200"/>
-            </a:lvl1pPr>
-          </a:lstStyle>
-          <a:p>
-            <a:endParaRPr lang="en-US"/>
-          </a:p>
-        </p:txBody>
-      </p:sp>
-      <p:sp>
-        <p:nvSpPr>
-          <p:cNvPr id="3" name="Date Placeholder 2"/>
-          <p:cNvSpPr>
-            <a:spLocks noGrp="1"/>
-          </p:cNvSpPr>
-          <p:nvPr>
-            <p:ph type="dt" idx="1"/>
-          </p:nvPr>
-        </p:nvSpPr>
-        <p:spPr>
-          <a:xfrm>
-            <a:off x="3884613" y="0"/>
-            <a:ext cx="2971800" cy="458788"/>
-          </a:xfrm>
-          <a:prstGeom prst="rect">
-            <a:avLst/>
-          </a:prstGeom>
-        </p:spPr>
-        <p:txBody>
-          <a:bodyPr vert="horz" lIns="91440" tIns="45720" rIns="91440" bIns="45720" rtlCol="0"/>
-          <a:lstStyle>
-            <a:lvl1pPr algn="r">
-              <a:defRPr sz="1200"/>
-            </a:lvl1pPr>
-          </a:lstStyle>
-          <a:p>
-            <a:fld id="{5282F153-3F37-0F45-9E97-73ACFA13230C}" type="datetimeFigureOut">
-              <a:rPr lang="en-US"/>
-              <a:t>7/23/19</a:t>
-            </a:fld>
-            <a:endParaRPr lang="en-US"/>
-          </a:p>
-        </p:txBody>
-      </p:sp>
-      <p:sp>
-        <p:nvSpPr>
-          <p:cNvPr id="4" name="Slide Image Placeholder 3"/>
-          <p:cNvSpPr>
-            <a:spLocks noGrp="1" noRot="1" noChangeAspect="1"/>
-          </p:cNvSpPr>
-          <p:nvPr>
-            <p:ph type="sldImg" idx="2"/>
-          </p:nvPr>
-        </p:nvSpPr>
-        <p:spPr>
-          <a:xfrm>
-            <a:off x="685800" y="1143000"/>
-            <a:ext cx="5486400" cy="3086100"/>
-          </a:xfrm>
-          <a:prstGeom prst="rect">
-            <a:avLst/>
-          </a:prstGeom>
-          <a:noFill/>
-          <a:ln w="12700">
-            <a:solidFill>
-              <a:prstClr val="black"/>
-            </a:solidFill>
-          </a:ln>
-        </p:spPr>
-        <p:txBody>
-          <a:bodyPr vert="horz" lIns="91440" tIns="45720" rIns="91440" bIns="45720" rtlCol="0" anchor="ctr"/>
-          <a:lstStyle/>
-          <a:p>
-            <a:endParaRPr lang="en-US"/>
-          </a:p>
-        </p:txBody>
-      </p:sp>
-      <p:sp>
-        <p:nvSpPr>
-          <p:cNvPr id="5" name="Notes Placeholder 4"/>
-          <p:cNvSpPr>
-            <a:spLocks noGrp="1"/>
-          </p:cNvSpPr>
-          <p:nvPr>
-            <p:ph type="body" sz="quarter" idx="3"/>
-          </p:nvPr>
-        </p:nvSpPr>
-        <p:spPr>
-          <a:xfrm>
-            <a:off x="685800" y="4400550"/>
-            <a:ext cx="5486400" cy="3600450"/>
-          </a:xfrm>
-          <a:prstGeom prst="rect">
-            <a:avLst/>
-          </a:prstGeom>
-        </p:spPr>
-        <p:txBody>
-          <a:bodyPr vert="horz" lIns="91440" tIns="45720" rIns="91440" bIns="45720" rtlCol="0"/>
-          <a:lstStyle/>
-          <a:p>
-            <a:pPr lvl="0"/>
-            <a:r>
-              <a:rPr lang="en-US"/>
-              <a:t>Click to edit Master text styles</a:t>
-            </a:r>
-          </a:p>
-          <a:p>
-            <a:pPr lvl="1"/>
-            <a:r>
-              <a:rPr lang="en-US"/>
-              <a:t>Second level</a:t>
-            </a:r>
-          </a:p>
-          <a:p>
-            <a:pPr lvl="2"/>
-            <a:r>
-              <a:rPr lang="en-US"/>
-              <a:t>Third level</a:t>
-            </a:r>
-          </a:p>
-          <a:p>
-            <a:pPr lvl="3"/>
-            <a:r>
-              <a:rPr lang="en-US"/>
-              <a:t>Fourth level</a:t>
-            </a:r>
-          </a:p>
-          <a:p>
-            <a:pPr lvl="4"/>
-            <a:r>
-              <a:rPr lang="en-US"/>
-              <a:t>Fifth level</a:t>
-            </a:r>
-          </a:p>
-        </p:txBody>
-      </p:sp>
-      <p:sp>
-        <p:nvSpPr>
-          <p:cNvPr id="6" name="Footer Placeholder 5"/>
-          <p:cNvSpPr>
-            <a:spLocks noGrp="1"/>
-          </p:cNvSpPr>
-          <p:nvPr>
-            <p:ph type="ftr" sz="quarter" idx="4"/>
-          </p:nvPr>
-        </p:nvSpPr>
-        <p:spPr>
-          <a:xfrm>
-            <a:off x="0" y="8685213"/>
-            <a:ext cx="2971800" cy="458787"/>
-          </a:xfrm>
-          <a:prstGeom prst="rect">
-            <a:avLst/>
-          </a:prstGeom>
-        </p:spPr>
-        <p:txBody>
-          <a:bodyPr vert="horz" lIns="91440" tIns="45720" rIns="91440" bIns="45720" rtlCol="0" anchor="b"/>
-          <a:lstStyle>
-            <a:lvl1pPr algn="l">
-              <a:defRPr sz="1200"/>
-            </a:lvl1pPr>
-          </a:lstStyle>
-          <a:p>
-            <a:endParaRPr lang="en-US"/>
-          </a:p>
-        </p:txBody>
-      </p:sp>
-      <p:sp>
-        <p:nvSpPr>
-          <p:cNvPr id="7" name="Slide Number Placeholder 6"/>
-          <p:cNvSpPr>
-            <a:spLocks noGrp="1"/>
-          </p:cNvSpPr>
-          <p:nvPr>
-            <p:ph type="sldNum" sz="quarter" idx="5"/>
-          </p:nvPr>
-        </p:nvSpPr>
-        <p:spPr>
-          <a:xfrm>
-            <a:off x="3884613" y="8685213"/>
-            <a:ext cx="2971800" cy="458787"/>
-          </a:xfrm>
-          <a:prstGeom prst="rect">
-            <a:avLst/>
-          </a:prstGeom>
-        </p:spPr>
-        <p:txBody>
-          <a:bodyPr vert="horz" lIns="91440" tIns="45720" rIns="91440" bIns="45720" rtlCol="0" anchor="b"/>
-          <a:lstStyle>
-            <a:lvl1pPr algn="r">
-              <a:defRPr sz="1200"/>
-            </a:lvl1pPr>
-          </a:lstStyle>
-          <a:p>
-            <a:fld id="{CE5E9CC1-C706-0F49-92D6-E571CC5EEA8F}" type="slidenum">
-              <a:rPr lang="en-US"/>
-              <a:t>‹#›</a:t>
-            </a:fld>
-            <a:endParaRPr lang="en-US"/>
-          </a:p>
-        </p:txBody>
-      </p:sp>
     </p:spTree>
     <p:extLst>
       <p:ext uri="{BB962C8B-B14F-4D97-AF65-F5344CB8AC3E}">
-        <p14:creationId xmlns:p14="http://schemas.microsoft.com/office/powerpoint/2010/main" val="1024086991"/>
+        <p14:creationId xmlns:p14="http://schemas.microsoft.com/office/powerpoint/2010/main" val="36045124"/>
       </p:ext>
     </p:extLst>
   </p:cSld>
@@ -513,10 +294,6 @@
           <a:bodyPr/>
           <a:lstStyle/>
           <a:p>
-            <a:r>
-              <a:rPr lang="en-US" dirty="0"/>
-              <a:t/>
-            </a:r>
             <a:endParaRPr lang="en-US" dirty="0"/>
           </a:p>
         </p:txBody>
@@ -601,10 +378,6 @@
           <a:bodyPr/>
           <a:lstStyle/>
           <a:p>
-            <a:r>
-              <a:rPr lang="en-US" dirty="0"/>
-              <a:t/>
-            </a:r>
             <a:endParaRPr lang="en-US" dirty="0"/>
           </a:p>
         </p:txBody>
@@ -689,10 +462,6 @@
           <a:bodyPr/>
           <a:lstStyle/>
           <a:p>
-            <a:r>
-              <a:rPr lang="en-US" dirty="0"/>
-              <a:t/>
-            </a:r>
             <a:endParaRPr lang="en-US" dirty="0"/>
           </a:p>
         </p:txBody>
@@ -777,10 +546,6 @@
           <a:bodyPr/>
           <a:lstStyle/>
           <a:p>
-            <a:r>
-              <a:rPr lang="en-US" dirty="0"/>
-              <a:t/>
-            </a:r>
             <a:endParaRPr lang="en-US" dirty="0"/>
           </a:p>
         </p:txBody>
@@ -865,10 +630,6 @@
           <a:bodyPr/>
           <a:lstStyle/>
           <a:p>
-            <a:r>
-              <a:rPr lang="en-US" dirty="0"/>
-              <a:t/>
-            </a:r>
             <a:endParaRPr lang="en-US" dirty="0"/>
           </a:p>
         </p:txBody>
@@ -957,7 +718,6 @@
               <a:rPr lang="en-US" dirty="0"/>
               <a:t>Transition line into the 14:00 Repo 1 Build session. Reinforce that everything just practiced (describe, generate, review, refine, debug) is the same loop they will run all afternoon, just pointed at a bigger target.</a:t>
             </a:r>
-            <a:endParaRPr lang="en-US" dirty="0"/>
           </a:p>
         </p:txBody>
       </p:sp>
@@ -1041,10 +801,6 @@
           <a:bodyPr/>
           <a:lstStyle/>
           <a:p>
-            <a:r>
-              <a:rPr lang="en-US" dirty="0"/>
-              <a:t/>
-            </a:r>
             <a:endParaRPr lang="en-US" dirty="0"/>
           </a:p>
         </p:txBody>
@@ -1129,10 +885,6 @@
           <a:bodyPr/>
           <a:lstStyle/>
           <a:p>
-            <a:r>
-              <a:rPr lang="en-US" dirty="0"/>
-              <a:t/>
-            </a:r>
             <a:endParaRPr lang="en-US" dirty="0"/>
           </a:p>
         </p:txBody>
@@ -1217,10 +969,6 @@
           <a:bodyPr/>
           <a:lstStyle/>
           <a:p>
-            <a:r>
-              <a:rPr lang="en-US" dirty="0"/>
-              <a:t/>
-            </a:r>
             <a:endParaRPr lang="en-US" dirty="0"/>
           </a:p>
         </p:txBody>
@@ -1305,10 +1053,6 @@
           <a:bodyPr/>
           <a:lstStyle/>
           <a:p>
-            <a:r>
-              <a:rPr lang="en-US" dirty="0"/>
-              <a:t/>
-            </a:r>
             <a:endParaRPr lang="en-US" dirty="0"/>
           </a:p>
         </p:txBody>
@@ -1393,10 +1137,6 @@
           <a:bodyPr/>
           <a:lstStyle/>
           <a:p>
-            <a:r>
-              <a:rPr lang="en-US" dirty="0"/>
-              <a:t/>
-            </a:r>
             <a:endParaRPr lang="en-US" dirty="0"/>
           </a:p>
         </p:txBody>
@@ -1481,10 +1221,6 @@
           <a:bodyPr/>
           <a:lstStyle/>
           <a:p>
-            <a:r>
-              <a:rPr lang="en-US" dirty="0"/>
-              <a:t/>
-            </a:r>
             <a:endParaRPr lang="en-US" dirty="0"/>
           </a:p>
         </p:txBody>
@@ -1569,10 +1305,6 @@
           <a:bodyPr/>
           <a:lstStyle/>
           <a:p>
-            <a:r>
-              <a:rPr lang="en-US" dirty="0"/>
-              <a:t/>
-            </a:r>
             <a:endParaRPr lang="en-US" dirty="0"/>
           </a:p>
         </p:txBody>
@@ -1657,10 +1389,6 @@
           <a:bodyPr/>
           <a:lstStyle/>
           <a:p>
-            <a:r>
-              <a:rPr lang="en-US" dirty="0"/>
-              <a:t/>
-            </a:r>
             <a:endParaRPr lang="en-US" dirty="0"/>
           </a:p>
         </p:txBody>
@@ -1734,6 +1462,11 @@
 <file path=ppt/slideMasters/slideMaster1.xml><?xml version="1.0" encoding="utf-8"?>
 <p:sldMaster xmlns:a="http://schemas.openxmlformats.org/drawingml/2006/main" xmlns:r="http://schemas.openxmlformats.org/officeDocument/2006/relationships" xmlns:p="http://schemas.openxmlformats.org/presentationml/2006/main">
   <p:cSld>
+    <p:bg>
+      <p:bgRef idx="1001">
+        <a:schemeClr val="bg1"/>
+      </p:bgRef>
+    </p:bg>
     <p:spTree>
       <p:nvGrpSpPr>
         <p:cNvPr id="1" name=""/>
@@ -2016,6 +1749,7 @@
         <a:solidFill>
           <a:srgbClr val="14213D"/>
         </a:solidFill>
+        <a:effectLst/>
       </p:bgPr>
     </p:bg>
     <p:spTree>
@@ -2098,14 +1832,14 @@
       </p:sp>
       <p:pic>
         <p:nvPicPr>
-          <p:cNvPr id="5" name="Image 0" descr="preencoded.png">    </p:cNvPr>
+          <p:cNvPr id="5" name="Image 0" descr="preencoded.png"/>
           <p:cNvPicPr>
             <a:picLocks noChangeAspect="1"/>
           </p:cNvPicPr>
           <p:nvPr/>
         </p:nvPicPr>
         <p:blipFill>
-          <a:blip r:embed="rId1"/>
+          <a:blip r:embed="rId3"/>
           <a:stretch>
             <a:fillRect/>
           </a:stretch>
@@ -2141,11 +1875,11 @@
           <a:bodyPr wrap="square" rtlCol="0" anchor="ctr"/>
           <a:lstStyle/>
           <a:p>
-            <a:pPr indent="0" marL="0">
-              <a:buNone/>
-            </a:pPr>
-            <a:r>
-              <a:rPr lang="en-US" sz="1300" b="1" spc="200" kern="0" dirty="0">
+            <a:pPr marL="0" indent="0">
+              <a:buNone/>
+            </a:pPr>
+            <a:r>
+              <a:rPr lang="en-US" sz="1300" b="1" kern="0" spc="200" dirty="0">
                 <a:solidFill>
                   <a:srgbClr val="9A6B2C"/>
                 </a:solidFill>
@@ -2180,7 +1914,7 @@
           <a:bodyPr wrap="square" rtlCol="0" anchor="ctr"/>
           <a:lstStyle/>
           <a:p>
-            <a:pPr indent="0" marL="0">
+            <a:pPr marL="0" indent="0">
               <a:lnSpc>
                 <a:spcPct val="105000"/>
               </a:lnSpc>
@@ -2200,7 +1934,7 @@
             <a:endParaRPr lang="en-US" sz="4600" dirty="0"/>
           </a:p>
           <a:p>
-            <a:pPr indent="0" marL="0">
+            <a:pPr marL="0" indent="0">
               <a:lnSpc>
                 <a:spcPct val="105000"/>
               </a:lnSpc>
@@ -2242,7 +1976,7 @@
           <a:bodyPr wrap="square" rtlCol="0" anchor="ctr"/>
           <a:lstStyle/>
           <a:p>
-            <a:pPr indent="0" marL="0">
+            <a:pPr marL="0" indent="0">
               <a:buNone/>
             </a:pPr>
             <a:r>
@@ -2281,7 +2015,7 @@
           <a:bodyPr wrap="square" rtlCol="0" anchor="ctr"/>
           <a:lstStyle/>
           <a:p>
-            <a:pPr indent="0" marL="0">
+            <a:pPr marL="0" indent="0">
               <a:buNone/>
             </a:pPr>
             <a:r>
@@ -2315,6 +2049,7 @@
         <a:solidFill>
           <a:srgbClr val="FAFAF7"/>
         </a:solidFill>
+        <a:effectLst/>
       </p:bgPr>
     </p:bg>
     <p:spTree>
@@ -2353,14 +2088,14 @@
       </p:sp>
       <p:pic>
         <p:nvPicPr>
-          <p:cNvPr id="3" name="Image 0" descr="preencoded.png">    </p:cNvPr>
+          <p:cNvPr id="3" name="Image 0" descr="preencoded.png"/>
           <p:cNvPicPr>
             <a:picLocks noChangeAspect="1"/>
           </p:cNvPicPr>
           <p:nvPr/>
         </p:nvPicPr>
         <p:blipFill>
-          <a:blip r:embed="rId1"/>
+          <a:blip r:embed="rId3"/>
           <a:stretch>
             <a:fillRect/>
           </a:stretch>
@@ -2396,11 +2131,11 @@
           <a:bodyPr wrap="square" rtlCol="0" anchor="ctr"/>
           <a:lstStyle/>
           <a:p>
-            <a:pPr indent="0" marL="0">
-              <a:buNone/>
-            </a:pPr>
-            <a:r>
-              <a:rPr lang="en-US" sz="1300" b="1" spc="100" kern="0" dirty="0">
+            <a:pPr marL="0" indent="0">
+              <a:buNone/>
+            </a:pPr>
+            <a:r>
+              <a:rPr lang="en-US" sz="1300" b="1" kern="0" spc="100" dirty="0">
                 <a:solidFill>
                   <a:srgbClr val="9A6B2C"/>
                 </a:solidFill>
@@ -2435,7 +2170,7 @@
           <a:bodyPr wrap="square" rtlCol="0" anchor="ctr"/>
           <a:lstStyle/>
           <a:p>
-            <a:pPr indent="0" marL="0">
+            <a:pPr marL="0" indent="0">
               <a:buNone/>
             </a:pPr>
             <a:r>
@@ -2474,7 +2209,7 @@
           <a:bodyPr wrap="square" rtlCol="0" anchor="ctr"/>
           <a:lstStyle/>
           <a:p>
-            <a:pPr indent="0" marL="0">
+            <a:pPr marL="0" indent="0">
               <a:buNone/>
             </a:pPr>
             <a:r>
@@ -2513,7 +2248,7 @@
           </a:solidFill>
           <a:ln/>
           <a:effectLst>
-            <a:outerShdw sx="100000" sy="100000" kx="0" ky="0" algn="bl" rotWithShape="0" blurRad="76200" dist="25400" dir="5400000">
+            <a:outerShdw blurRad="76200" dist="25400" dir="5400000" algn="bl" rotWithShape="0">
               <a:srgbClr val="000000">
                 <a:alpha val="8000"/>
               </a:srgbClr>
@@ -2564,7 +2299,7 @@
           <a:bodyPr wrap="square" rtlCol="0" anchor="ctr"/>
           <a:lstStyle/>
           <a:p>
-            <a:pPr algn="ctr" indent="0" marL="0">
+            <a:pPr marL="0" indent="0" algn="ctr">
               <a:buNone/>
             </a:pPr>
             <a:r>
@@ -2603,7 +2338,7 @@
           <a:bodyPr wrap="square" rtlCol="0" anchor="ctr"/>
           <a:lstStyle/>
           <a:p>
-            <a:pPr indent="0" marL="0">
+            <a:pPr marL="0" indent="0">
               <a:lnSpc>
                 <a:spcPct val="130000"/>
               </a:lnSpc>
@@ -2623,7 +2358,7 @@
             <a:endParaRPr lang="en-US" sz="1400" dirty="0"/>
           </a:p>
           <a:p>
-            <a:pPr indent="0" marL="0">
+            <a:pPr marL="0" indent="0">
               <a:lnSpc>
                 <a:spcPct val="130000"/>
               </a:lnSpc>
@@ -2665,7 +2400,7 @@
           </a:solidFill>
           <a:ln/>
           <a:effectLst>
-            <a:outerShdw sx="100000" sy="100000" kx="0" ky="0" algn="bl" rotWithShape="0" blurRad="76200" dist="25400" dir="5400000">
+            <a:outerShdw blurRad="76200" dist="25400" dir="5400000" algn="bl" rotWithShape="0">
               <a:srgbClr val="000000">
                 <a:alpha val="8000"/>
               </a:srgbClr>
@@ -2716,7 +2451,7 @@
           <a:bodyPr wrap="square" rtlCol="0" anchor="ctr"/>
           <a:lstStyle/>
           <a:p>
-            <a:pPr algn="ctr" indent="0" marL="0">
+            <a:pPr marL="0" indent="0" algn="ctr">
               <a:buNone/>
             </a:pPr>
             <a:r>
@@ -2755,7 +2490,7 @@
           <a:bodyPr wrap="square" rtlCol="0" anchor="ctr"/>
           <a:lstStyle/>
           <a:p>
-            <a:pPr indent="0" marL="0">
+            <a:pPr marL="0" indent="0">
               <a:lnSpc>
                 <a:spcPct val="130000"/>
               </a:lnSpc>
@@ -2775,7 +2510,7 @@
             <a:endParaRPr lang="en-US" sz="1400" dirty="0"/>
           </a:p>
           <a:p>
-            <a:pPr indent="0" marL="0">
+            <a:pPr marL="0" indent="0">
               <a:lnSpc>
                 <a:spcPct val="130000"/>
               </a:lnSpc>
@@ -2817,7 +2552,7 @@
           <a:bodyPr wrap="square" rtlCol="0" anchor="ctr"/>
           <a:lstStyle/>
           <a:p>
-            <a:pPr indent="0" marL="0">
+            <a:pPr marL="0" indent="0">
               <a:buNone/>
             </a:pPr>
             <a:r>
@@ -2851,6 +2586,7 @@
         <a:solidFill>
           <a:srgbClr val="FAFAF7"/>
         </a:solidFill>
+        <a:effectLst/>
       </p:bgPr>
     </p:bg>
     <p:spTree>
@@ -2888,7 +2624,7 @@
           <a:bodyPr wrap="square" rtlCol="0" anchor="ctr"/>
           <a:lstStyle/>
           <a:p>
-            <a:pPr indent="0" marL="0">
+            <a:pPr marL="0" indent="0">
               <a:buNone/>
             </a:pPr>
             <a:r>
@@ -2929,8 +2665,20 @@
             <a:tbl>
               <a:tblPr/>
               <a:tblGrid>
-                <a:gridCol w="3840480"/>
-                <a:gridCol w="7223760"/>
+                <a:gridCol w="3840480">
+                  <a:extLst>
+                    <a:ext uri="{9D8B030D-6E8A-4147-A177-3AD203B41FA5}">
+                      <a16:colId xmlns:a16="http://schemas.microsoft.com/office/drawing/2014/main" val="20000"/>
+                    </a:ext>
+                  </a:extLst>
+                </a:gridCol>
+                <a:gridCol w="7223760">
+                  <a:extLst>
+                    <a:ext uri="{9D8B030D-6E8A-4147-A177-3AD203B41FA5}">
+                      <a16:colId xmlns:a16="http://schemas.microsoft.com/office/drawing/2014/main" val="20001"/>
+                    </a:ext>
+                  </a:extLst>
+                </a:gridCol>
               </a:tblGrid>
               <a:tr h="822960">
                 <a:tc>
@@ -2938,7 +2686,7 @@
                     <a:bodyPr/>
                     <a:lstStyle/>
                     <a:p>
-                      <a:pPr indent="0" marL="0">
+                      <a:pPr marL="0" indent="0">
                         <a:buNone/>
                       </a:pPr>
                       <a:r>
@@ -2959,7 +2707,7 @@
                       </a:endParaRPr>
                     </a:p>
                   </a:txBody>
-                  <a:tcPr marL="91440" marR="91440" marT="45720" marB="45720">
+                  <a:tcPr>
                     <a:lnL w="0" cap="flat" cmpd="sng" algn="ctr">
                       <a:solidFill>
                         <a:srgbClr val="FAFAF7"/>
@@ -3006,7 +2754,7 @@
                     <a:bodyPr/>
                     <a:lstStyle/>
                     <a:p>
-                      <a:pPr indent="0" marL="0">
+                      <a:pPr marL="0" indent="0">
                         <a:buNone/>
                       </a:pPr>
                       <a:r>
@@ -3027,7 +2775,7 @@
                       </a:endParaRPr>
                     </a:p>
                   </a:txBody>
-                  <a:tcPr marL="91440" marR="91440" marT="45720" marB="45720">
+                  <a:tcPr>
                     <a:lnL w="0" cap="flat" cmpd="sng" algn="ctr">
                       <a:solidFill>
                         <a:srgbClr val="FAFAF7"/>
@@ -3069,6 +2817,11 @@
                     </a:solidFill>
                   </a:tcPr>
                 </a:tc>
+                <a:extLst>
+                  <a:ext uri="{0D108BD9-81ED-4DB2-BD59-A6C34878D82A}">
+                    <a16:rowId xmlns:a16="http://schemas.microsoft.com/office/drawing/2014/main" val="10000"/>
+                  </a:ext>
+                </a:extLst>
               </a:tr>
               <a:tr h="822960">
                 <a:tc>
@@ -3076,7 +2829,7 @@
                     <a:bodyPr/>
                     <a:lstStyle/>
                     <a:p>
-                      <a:pPr indent="0" marL="0">
+                      <a:pPr marL="0" indent="0">
                         <a:buNone/>
                       </a:pPr>
                       <a:r>
@@ -3097,7 +2850,7 @@
                       </a:endParaRPr>
                     </a:p>
                   </a:txBody>
-                  <a:tcPr marL="91440" marR="91440" marT="45720" marB="45720">
+                  <a:tcPr>
                     <a:lnL w="0" cap="flat" cmpd="sng" algn="ctr">
                       <a:solidFill>
                         <a:srgbClr val="FAFAF7"/>
@@ -3144,7 +2897,7 @@
                     <a:bodyPr/>
                     <a:lstStyle/>
                     <a:p>
-                      <a:pPr indent="0" marL="0">
+                      <a:pPr marL="0" indent="0">
                         <a:buNone/>
                       </a:pPr>
                       <a:r>
@@ -3165,7 +2918,7 @@
                       </a:endParaRPr>
                     </a:p>
                   </a:txBody>
-                  <a:tcPr marL="91440" marR="91440" marT="45720" marB="45720">
+                  <a:tcPr>
                     <a:lnL w="0" cap="flat" cmpd="sng" algn="ctr">
                       <a:solidFill>
                         <a:srgbClr val="FAFAF7"/>
@@ -3207,6 +2960,11 @@
                     </a:solidFill>
                   </a:tcPr>
                 </a:tc>
+                <a:extLst>
+                  <a:ext uri="{0D108BD9-81ED-4DB2-BD59-A6C34878D82A}">
+                    <a16:rowId xmlns:a16="http://schemas.microsoft.com/office/drawing/2014/main" val="10001"/>
+                  </a:ext>
+                </a:extLst>
               </a:tr>
               <a:tr h="822960">
                 <a:tc>
@@ -3214,7 +2972,7 @@
                     <a:bodyPr/>
                     <a:lstStyle/>
                     <a:p>
-                      <a:pPr indent="0" marL="0">
+                      <a:pPr marL="0" indent="0">
                         <a:buNone/>
                       </a:pPr>
                       <a:r>
@@ -3235,7 +2993,7 @@
                       </a:endParaRPr>
                     </a:p>
                   </a:txBody>
-                  <a:tcPr marL="91440" marR="91440" marT="45720" marB="45720">
+                  <a:tcPr>
                     <a:lnL w="0" cap="flat" cmpd="sng" algn="ctr">
                       <a:solidFill>
                         <a:srgbClr val="FAFAF7"/>
@@ -3282,7 +3040,7 @@
                     <a:bodyPr/>
                     <a:lstStyle/>
                     <a:p>
-                      <a:pPr indent="0" marL="0">
+                      <a:pPr marL="0" indent="0">
                         <a:buNone/>
                       </a:pPr>
                       <a:r>
@@ -3303,7 +3061,7 @@
                       </a:endParaRPr>
                     </a:p>
                   </a:txBody>
-                  <a:tcPr marL="91440" marR="91440" marT="45720" marB="45720">
+                  <a:tcPr>
                     <a:lnL w="0" cap="flat" cmpd="sng" algn="ctr">
                       <a:solidFill>
                         <a:srgbClr val="FAFAF7"/>
@@ -3345,6 +3103,11 @@
                     </a:solidFill>
                   </a:tcPr>
                 </a:tc>
+                <a:extLst>
+                  <a:ext uri="{0D108BD9-81ED-4DB2-BD59-A6C34878D82A}">
+                    <a16:rowId xmlns:a16="http://schemas.microsoft.com/office/drawing/2014/main" val="10002"/>
+                  </a:ext>
+                </a:extLst>
               </a:tr>
               <a:tr h="822960">
                 <a:tc>
@@ -3352,7 +3115,7 @@
                     <a:bodyPr/>
                     <a:lstStyle/>
                     <a:p>
-                      <a:pPr indent="0" marL="0">
+                      <a:pPr marL="0" indent="0">
                         <a:buNone/>
                       </a:pPr>
                       <a:r>
@@ -3373,7 +3136,7 @@
                       </a:endParaRPr>
                     </a:p>
                   </a:txBody>
-                  <a:tcPr marL="91440" marR="91440" marT="45720" marB="45720">
+                  <a:tcPr>
                     <a:lnL w="0" cap="flat" cmpd="sng" algn="ctr">
                       <a:solidFill>
                         <a:srgbClr val="FAFAF7"/>
@@ -3420,7 +3183,7 @@
                     <a:bodyPr/>
                     <a:lstStyle/>
                     <a:p>
-                      <a:pPr indent="0" marL="0">
+                      <a:pPr marL="0" indent="0">
                         <a:buNone/>
                       </a:pPr>
                       <a:r>
@@ -3441,7 +3204,7 @@
                       </a:endParaRPr>
                     </a:p>
                   </a:txBody>
-                  <a:tcPr marL="91440" marR="91440" marT="45720" marB="45720">
+                  <a:tcPr>
                     <a:lnL w="0" cap="flat" cmpd="sng" algn="ctr">
                       <a:solidFill>
                         <a:srgbClr val="FAFAF7"/>
@@ -3483,6 +3246,11 @@
                     </a:solidFill>
                   </a:tcPr>
                 </a:tc>
+                <a:extLst>
+                  <a:ext uri="{0D108BD9-81ED-4DB2-BD59-A6C34878D82A}">
+                    <a16:rowId xmlns:a16="http://schemas.microsoft.com/office/drawing/2014/main" val="10003"/>
+                  </a:ext>
+                </a:extLst>
               </a:tr>
             </a:tbl>
           </a:graphicData>
@@ -3509,7 +3277,7 @@
           <a:bodyPr wrap="square" rtlCol="0" anchor="ctr"/>
           <a:lstStyle/>
           <a:p>
-            <a:pPr indent="0" marL="0">
+            <a:pPr marL="0" indent="0">
               <a:buNone/>
             </a:pPr>
             <a:r>
@@ -3543,6 +3311,7 @@
         <a:solidFill>
           <a:srgbClr val="14213D"/>
         </a:solidFill>
+        <a:effectLst/>
       </p:bgPr>
     </p:bg>
     <p:spTree>
@@ -3581,14 +3350,14 @@
       </p:sp>
       <p:pic>
         <p:nvPicPr>
-          <p:cNvPr id="3" name="Image 0" descr="preencoded.png">    </p:cNvPr>
+          <p:cNvPr id="3" name="Image 0" descr="preencoded.png"/>
           <p:cNvPicPr>
             <a:picLocks noChangeAspect="1"/>
           </p:cNvPicPr>
           <p:nvPr/>
         </p:nvPicPr>
         <p:blipFill>
-          <a:blip r:embed="rId1"/>
+          <a:blip r:embed="rId3"/>
           <a:stretch>
             <a:fillRect/>
           </a:stretch>
@@ -3624,7 +3393,7 @@
           <a:bodyPr wrap="square" rtlCol="0" anchor="ctr"/>
           <a:lstStyle/>
           <a:p>
-            <a:pPr indent="0" marL="0">
+            <a:pPr marL="0" indent="0">
               <a:buNone/>
             </a:pPr>
             <a:r>
@@ -3663,7 +3432,7 @@
           <a:bodyPr wrap="square" rtlCol="0" anchor="ctr"/>
           <a:lstStyle/>
           <a:p>
-            <a:pPr indent="0" marL="0">
+            <a:pPr marL="0" indent="0">
               <a:buNone/>
             </a:pPr>
             <a:r>
@@ -3724,7 +3493,7 @@
           <a:bodyPr wrap="square" rtlCol="0" anchor="ctr"/>
           <a:lstStyle/>
           <a:p>
-            <a:pPr indent="0" marL="0">
+            <a:pPr marL="0" indent="0">
               <a:buNone/>
             </a:pPr>
             <a:r>
@@ -3763,7 +3532,7 @@
           <a:bodyPr wrap="square" rtlCol="0" anchor="ctr"/>
           <a:lstStyle/>
           <a:p>
-            <a:pPr indent="0" marL="0">
+            <a:pPr marL="0" indent="0">
               <a:lnSpc>
                 <a:spcPct val="125000"/>
               </a:lnSpc>
@@ -3920,6 +3689,7 @@
         <a:solidFill>
           <a:srgbClr val="FAFAF7"/>
         </a:solidFill>
+        <a:effectLst/>
       </p:bgPr>
     </p:bg>
     <p:spTree>
@@ -3985,14 +3755,14 @@
       </p:sp>
       <p:pic>
         <p:nvPicPr>
-          <p:cNvPr id="4" name="Image 0" descr="preencoded.png">    </p:cNvPr>
+          <p:cNvPr id="4" name="Image 0" descr="preencoded.png"/>
           <p:cNvPicPr>
             <a:picLocks noChangeAspect="1"/>
           </p:cNvPicPr>
           <p:nvPr/>
         </p:nvPicPr>
         <p:blipFill>
-          <a:blip r:embed="rId1"/>
+          <a:blip r:embed="rId3"/>
           <a:stretch>
             <a:fillRect/>
           </a:stretch>
@@ -4028,7 +3798,7 @@
           <a:bodyPr wrap="square" rtlCol="0" anchor="ctr"/>
           <a:lstStyle/>
           <a:p>
-            <a:pPr indent="0" marL="0">
+            <a:pPr marL="0" indent="0">
               <a:buNone/>
             </a:pPr>
             <a:r>
@@ -4067,7 +3837,7 @@
           <a:bodyPr wrap="square" rtlCol="0" anchor="ctr"/>
           <a:lstStyle/>
           <a:p>
-            <a:pPr indent="0" marL="0">
+            <a:pPr marL="0" indent="0">
               <a:buNone/>
             </a:pPr>
             <a:r>
@@ -4106,7 +3876,7 @@
           <a:bodyPr wrap="square" rtlCol="0" anchor="ctr"/>
           <a:lstStyle/>
           <a:p>
-            <a:pPr indent="0" marL="0">
+            <a:pPr marL="0" indent="0">
               <a:buNone/>
             </a:pPr>
             <a:r>
@@ -4145,7 +3915,7 @@
           <a:bodyPr wrap="square" rtlCol="0" anchor="ctr"/>
           <a:lstStyle/>
           <a:p>
-            <a:pPr indent="0" marL="0">
+            <a:pPr marL="0" indent="0">
               <a:buNone/>
             </a:pPr>
             <a:r>
@@ -4184,7 +3954,7 @@
           <a:bodyPr wrap="square" rtlCol="0" anchor="ctr"/>
           <a:lstStyle/>
           <a:p>
-            <a:pPr indent="0" marL="0">
+            <a:pPr marL="0" indent="0">
               <a:buNone/>
             </a:pPr>
             <a:r>
@@ -4223,7 +3993,7 @@
           <a:bodyPr wrap="square" rtlCol="0" anchor="ctr"/>
           <a:lstStyle/>
           <a:p>
-            <a:pPr indent="0" marL="0">
+            <a:pPr marL="0" indent="0">
               <a:buNone/>
             </a:pPr>
             <a:r>
@@ -4262,7 +4032,7 @@
           <a:bodyPr wrap="square" rtlCol="0" anchor="ctr"/>
           <a:lstStyle/>
           <a:p>
-            <a:pPr indent="0" marL="0">
+            <a:pPr marL="0" indent="0">
               <a:buNone/>
             </a:pPr>
             <a:r>
@@ -4301,7 +4071,7 @@
           <a:bodyPr wrap="square" rtlCol="0" anchor="ctr"/>
           <a:lstStyle/>
           <a:p>
-            <a:pPr indent="0" marL="0">
+            <a:pPr marL="0" indent="0">
               <a:buNone/>
             </a:pPr>
             <a:r>
@@ -4340,7 +4110,7 @@
           <a:bodyPr wrap="square" rtlCol="0" anchor="ctr"/>
           <a:lstStyle/>
           <a:p>
-            <a:pPr indent="0" marL="0">
+            <a:pPr marL="0" indent="0">
               <a:buNone/>
             </a:pPr>
             <a:r>
@@ -4374,6 +4144,7 @@
         <a:solidFill>
           <a:srgbClr val="14213D"/>
         </a:solidFill>
+        <a:effectLst/>
       </p:bgPr>
     </p:bg>
     <p:spTree>
@@ -4412,14 +4183,14 @@
       </p:sp>
       <p:pic>
         <p:nvPicPr>
-          <p:cNvPr id="3" name="Image 0" descr="preencoded.png">    </p:cNvPr>
+          <p:cNvPr id="3" name="Image 0" descr="preencoded.png"/>
           <p:cNvPicPr>
             <a:picLocks noChangeAspect="1"/>
           </p:cNvPicPr>
           <p:nvPr/>
         </p:nvPicPr>
         <p:blipFill>
-          <a:blip r:embed="rId1"/>
+          <a:blip r:embed="rId3"/>
           <a:stretch>
             <a:fillRect/>
           </a:stretch>
@@ -4455,7 +4226,7 @@
           <a:bodyPr wrap="square" rtlCol="0" anchor="ctr"/>
           <a:lstStyle/>
           <a:p>
-            <a:pPr indent="0" marL="0">
+            <a:pPr marL="0" indent="0">
               <a:buNone/>
             </a:pPr>
             <a:r>
@@ -4514,7 +4285,7 @@
           <a:bodyPr wrap="square" rtlCol="0" anchor="ctr"/>
           <a:lstStyle/>
           <a:p>
-            <a:pPr indent="0" marL="0">
+            <a:pPr marL="0" indent="0">
               <a:buNone/>
             </a:pPr>
             <a:r>
@@ -4573,7 +4344,7 @@
           <a:bodyPr wrap="square" rtlCol="0" anchor="ctr"/>
           <a:lstStyle/>
           <a:p>
-            <a:pPr indent="0" marL="0">
+            <a:pPr marL="0" indent="0">
               <a:buNone/>
             </a:pPr>
             <a:r>
@@ -4632,7 +4403,7 @@
           <a:bodyPr wrap="square" rtlCol="0" anchor="ctr"/>
           <a:lstStyle/>
           <a:p>
-            <a:pPr indent="0" marL="0">
+            <a:pPr marL="0" indent="0">
               <a:buNone/>
             </a:pPr>
             <a:r>
@@ -4691,7 +4462,7 @@
           <a:bodyPr wrap="square" rtlCol="0" anchor="ctr"/>
           <a:lstStyle/>
           <a:p>
-            <a:pPr indent="0" marL="0">
+            <a:pPr marL="0" indent="0">
               <a:buNone/>
             </a:pPr>
             <a:r>
@@ -4750,7 +4521,7 @@
           <a:bodyPr wrap="square" rtlCol="0" anchor="ctr"/>
           <a:lstStyle/>
           <a:p>
-            <a:pPr indent="0" marL="0">
+            <a:pPr marL="0" indent="0">
               <a:buNone/>
             </a:pPr>
             <a:r>
@@ -4789,7 +4560,7 @@
           <a:bodyPr wrap="square" rtlCol="0" anchor="ctr"/>
           <a:lstStyle/>
           <a:p>
-            <a:pPr indent="0" marL="0">
+            <a:pPr marL="0" indent="0">
               <a:buNone/>
             </a:pPr>
             <a:r>
@@ -4823,6 +4594,7 @@
         <a:solidFill>
           <a:srgbClr val="FAFAF7"/>
         </a:solidFill>
+        <a:effectLst/>
       </p:bgPr>
     </p:bg>
     <p:spTree>
@@ -4860,7 +4632,7 @@
           <a:bodyPr wrap="square" rtlCol="0" anchor="ctr"/>
           <a:lstStyle/>
           <a:p>
-            <a:pPr indent="0" marL="0">
+            <a:pPr marL="0" indent="0">
               <a:buNone/>
             </a:pPr>
             <a:r>
@@ -4899,7 +4671,7 @@
           <a:bodyPr wrap="square" rtlCol="0" anchor="ctr"/>
           <a:lstStyle/>
           <a:p>
-            <a:pPr indent="0" marL="0">
+            <a:pPr marL="0" indent="0">
               <a:buNone/>
             </a:pPr>
             <a:r>
@@ -4938,7 +4710,7 @@
           </a:solidFill>
           <a:ln/>
           <a:effectLst>
-            <a:outerShdw sx="100000" sy="100000" kx="0" ky="0" algn="bl" rotWithShape="0" blurRad="63500" dist="25400" dir="5400000">
+            <a:outerShdw blurRad="63500" dist="25400" dir="5400000" algn="bl" rotWithShape="0">
               <a:srgbClr val="000000">
                 <a:alpha val="8000"/>
               </a:srgbClr>
@@ -4968,309 +4740,7 @@
       </p:sp>
       <p:pic>
         <p:nvPicPr>
-          <p:cNvPr id="6" name="Image 0" descr="preencoded.png">    </p:cNvPr>
-          <p:cNvPicPr>
-            <a:picLocks noChangeAspect="1"/>
-          </p:cNvPicPr>
-          <p:nvPr/>
-        </p:nvPicPr>
-        <p:blipFill>
-          <a:blip r:embed="rId1"/>
-          <a:stretch>
-            <a:fillRect/>
-          </a:stretch>
-        </p:blipFill>
-        <p:spPr>
-          <a:xfrm>
-            <a:off x="838688" y="1871960"/>
-            <a:ext cx="389169" cy="389169"/>
-          </a:xfrm>
-          <a:prstGeom prst="rect">
-            <a:avLst/>
-          </a:prstGeom>
-        </p:spPr>
-      </p:pic>
-      <p:sp>
-        <p:nvSpPr>
-          <p:cNvPr id="7" name="Text 4"/>
-          <p:cNvSpPr/>
-          <p:nvPr/>
-        </p:nvSpPr>
-        <p:spPr>
-          <a:xfrm>
-            <a:off x="1508760" y="1664208"/>
-            <a:ext cx="9784080" cy="365760"/>
-          </a:xfrm>
-          <a:prstGeom prst="rect">
-            <a:avLst/>
-          </a:prstGeom>
-          <a:noFill/>
-          <a:ln/>
-        </p:spPr>
-        <p:txBody>
-          <a:bodyPr wrap="square" rtlCol="0" anchor="ctr"/>
-          <a:lstStyle/>
-          <a:p>
-            <a:pPr indent="0" marL="0">
-              <a:buNone/>
-            </a:pPr>
-            <a:r>
-              <a:rPr lang="en-US" sz="1550" b="1" dirty="0">
-                <a:solidFill>
-                  <a:srgbClr val="14213D"/>
-                </a:solidFill>
-                <a:latin typeface="Calibri" pitchFamily="34" charset="0"/>
-                <a:ea typeface="Calibri" pitchFamily="34" charset="-122"/>
-                <a:cs typeface="Calibri" pitchFamily="34" charset="-120"/>
-              </a:rPr>
-              <a:t>What vibe coding is, and when it is appropriate</a:t>
-            </a:r>
-            <a:endParaRPr lang="en-US" sz="1550" dirty="0"/>
-          </a:p>
-        </p:txBody>
-      </p:sp>
-      <p:sp>
-        <p:nvSpPr>
-          <p:cNvPr id="8" name="Text 5"/>
-          <p:cNvSpPr/>
-          <p:nvPr/>
-        </p:nvSpPr>
-        <p:spPr>
-          <a:xfrm>
-            <a:off x="1508760" y="2011680"/>
-            <a:ext cx="9784080" cy="457200"/>
-          </a:xfrm>
-          <a:prstGeom prst="rect">
-            <a:avLst/>
-          </a:prstGeom>
-          <a:noFill/>
-          <a:ln/>
-        </p:spPr>
-        <p:txBody>
-          <a:bodyPr wrap="square" rtlCol="0" anchor="ctr"/>
-          <a:lstStyle/>
-          <a:p>
-            <a:pPr indent="0" marL="0">
-              <a:buNone/>
-            </a:pPr>
-            <a:r>
-              <a:rPr lang="en-US" sz="1250" dirty="0">
-                <a:solidFill>
-                  <a:srgbClr val="3A3F4B"/>
-                </a:solidFill>
-                <a:latin typeface="Calibri" pitchFamily="34" charset="0"/>
-                <a:ea typeface="Calibri" pitchFamily="34" charset="-122"/>
-                <a:cs typeface="Calibri" pitchFamily="34" charset="-120"/>
-              </a:rPr>
-              <a:t>Knowledge &amp; understanding: capabilities and limitations of LLM-assisted development</a:t>
-            </a:r>
-            <a:endParaRPr lang="en-US" sz="1250" dirty="0"/>
-          </a:p>
-        </p:txBody>
-      </p:sp>
-      <p:sp>
-        <p:nvSpPr>
-          <p:cNvPr id="9" name="Shape 6"/>
-          <p:cNvSpPr/>
-          <p:nvPr/>
-        </p:nvSpPr>
-        <p:spPr>
-          <a:xfrm>
-            <a:off x="548640" y="2743200"/>
-            <a:ext cx="11064240" cy="1024128"/>
-          </a:xfrm>
-          <a:prstGeom prst="roundRect">
-            <a:avLst>
-              <a:gd name="adj" fmla="val 5357"/>
-            </a:avLst>
-          </a:prstGeom>
-          <a:solidFill>
-            <a:srgbClr val="FFFFFF"/>
-          </a:solidFill>
-          <a:ln/>
-          <a:effectLst>
-            <a:outerShdw sx="100000" sy="100000" kx="0" ky="0" algn="bl" rotWithShape="0" blurRad="63500" dist="25400" dir="5400000">
-              <a:srgbClr val="000000">
-                <a:alpha val="8000"/>
-              </a:srgbClr>
-            </a:outerShdw>
-          </a:effectLst>
-        </p:spPr>
-      </p:sp>
-      <p:sp>
-        <p:nvSpPr>
-          <p:cNvPr id="10" name="Shape 7"/>
-          <p:cNvSpPr/>
-          <p:nvPr/>
-        </p:nvSpPr>
-        <p:spPr>
-          <a:xfrm>
-            <a:off x="777240" y="2999232"/>
-            <a:ext cx="512064" cy="512064"/>
-          </a:xfrm>
-          <a:prstGeom prst="ellipse">
-            <a:avLst/>
-          </a:prstGeom>
-          <a:solidFill>
-            <a:srgbClr val="F1EEE3"/>
-          </a:solidFill>
-          <a:ln/>
-        </p:spPr>
-      </p:sp>
-      <p:pic>
-        <p:nvPicPr>
-          <p:cNvPr id="11" name="Image 1" descr="preencoded.png">    </p:cNvPr>
-          <p:cNvPicPr>
-            <a:picLocks noChangeAspect="1"/>
-          </p:cNvPicPr>
-          <p:nvPr/>
-        </p:nvPicPr>
-        <p:blipFill>
-          <a:blip r:embed="rId2"/>
-          <a:stretch>
-            <a:fillRect/>
-          </a:stretch>
-        </p:blipFill>
-        <p:spPr>
-          <a:xfrm>
-            <a:off x="838688" y="3060680"/>
-            <a:ext cx="389169" cy="389169"/>
-          </a:xfrm>
-          <a:prstGeom prst="rect">
-            <a:avLst/>
-          </a:prstGeom>
-        </p:spPr>
-      </p:pic>
-      <p:sp>
-        <p:nvSpPr>
-          <p:cNvPr id="12" name="Text 8"/>
-          <p:cNvSpPr/>
-          <p:nvPr/>
-        </p:nvSpPr>
-        <p:spPr>
-          <a:xfrm>
-            <a:off x="1508760" y="2852928"/>
-            <a:ext cx="9784080" cy="365760"/>
-          </a:xfrm>
-          <a:prstGeom prst="rect">
-            <a:avLst/>
-          </a:prstGeom>
-          <a:noFill/>
-          <a:ln/>
-        </p:spPr>
-        <p:txBody>
-          <a:bodyPr wrap="square" rtlCol="0" anchor="ctr"/>
-          <a:lstStyle/>
-          <a:p>
-            <a:pPr indent="0" marL="0">
-              <a:buNone/>
-            </a:pPr>
-            <a:r>
-              <a:rPr lang="en-US" sz="1550" b="1" dirty="0">
-                <a:solidFill>
-                  <a:srgbClr val="14213D"/>
-                </a:solidFill>
-                <a:latin typeface="Calibri" pitchFamily="34" charset="0"/>
-                <a:ea typeface="Calibri" pitchFamily="34" charset="-122"/>
-                <a:cs typeface="Calibri" pitchFamily="34" charset="-120"/>
-              </a:rPr>
-              <a:t>The describe → generate → review → refine workflow</a:t>
-            </a:r>
-            <a:endParaRPr lang="en-US" sz="1550" dirty="0"/>
-          </a:p>
-        </p:txBody>
-      </p:sp>
-      <p:sp>
-        <p:nvSpPr>
-          <p:cNvPr id="13" name="Text 9"/>
-          <p:cNvSpPr/>
-          <p:nvPr/>
-        </p:nvSpPr>
-        <p:spPr>
-          <a:xfrm>
-            <a:off x="1508760" y="3200400"/>
-            <a:ext cx="9784080" cy="457200"/>
-          </a:xfrm>
-          <a:prstGeom prst="rect">
-            <a:avLst/>
-          </a:prstGeom>
-          <a:noFill/>
-          <a:ln/>
-        </p:spPr>
-        <p:txBody>
-          <a:bodyPr wrap="square" rtlCol="0" anchor="ctr"/>
-          <a:lstStyle/>
-          <a:p>
-            <a:pPr indent="0" marL="0">
-              <a:buNone/>
-            </a:pPr>
-            <a:r>
-              <a:rPr lang="en-US" sz="1250" dirty="0">
-                <a:solidFill>
-                  <a:srgbClr val="3A3F4B"/>
-                </a:solidFill>
-                <a:latin typeface="Calibri" pitchFamily="34" charset="0"/>
-                <a:ea typeface="Calibri" pitchFamily="34" charset="-122"/>
-                <a:cs typeface="Calibri" pitchFamily="34" charset="-120"/>
-              </a:rPr>
-              <a:t>Cognitive skill: translating an investment thesis into functional requirements a model can act on</a:t>
-            </a:r>
-            <a:endParaRPr lang="en-US" sz="1250" dirty="0"/>
-          </a:p>
-        </p:txBody>
-      </p:sp>
-      <p:sp>
-        <p:nvSpPr>
-          <p:cNvPr id="14" name="Shape 10"/>
-          <p:cNvSpPr/>
-          <p:nvPr/>
-        </p:nvSpPr>
-        <p:spPr>
-          <a:xfrm>
-            <a:off x="548640" y="3931920"/>
-            <a:ext cx="11064240" cy="1024128"/>
-          </a:xfrm>
-          <a:prstGeom prst="roundRect">
-            <a:avLst>
-              <a:gd name="adj" fmla="val 5357"/>
-            </a:avLst>
-          </a:prstGeom>
-          <a:solidFill>
-            <a:srgbClr val="FFFFFF"/>
-          </a:solidFill>
-          <a:ln/>
-          <a:effectLst>
-            <a:outerShdw sx="100000" sy="100000" kx="0" ky="0" algn="bl" rotWithShape="0" blurRad="63500" dist="25400" dir="5400000">
-              <a:srgbClr val="000000">
-                <a:alpha val="8000"/>
-              </a:srgbClr>
-            </a:outerShdw>
-          </a:effectLst>
-        </p:spPr>
-      </p:sp>
-      <p:sp>
-        <p:nvSpPr>
-          <p:cNvPr id="15" name="Shape 11"/>
-          <p:cNvSpPr/>
-          <p:nvPr/>
-        </p:nvSpPr>
-        <p:spPr>
-          <a:xfrm>
-            <a:off x="777240" y="4187952"/>
-            <a:ext cx="512064" cy="512064"/>
-          </a:xfrm>
-          <a:prstGeom prst="ellipse">
-            <a:avLst/>
-          </a:prstGeom>
-          <a:solidFill>
-            <a:srgbClr val="F1EEE3"/>
-          </a:solidFill>
-          <a:ln/>
-        </p:spPr>
-      </p:sp>
-      <p:pic>
-        <p:nvPicPr>
-          <p:cNvPr id="16" name="Image 2" descr="preencoded.png">    </p:cNvPr>
+          <p:cNvPr id="6" name="Image 0" descr="preencoded.png"/>
           <p:cNvPicPr>
             <a:picLocks noChangeAspect="1"/>
           </p:cNvPicPr>
@@ -5284,7 +4754,7 @@
         </p:blipFill>
         <p:spPr>
           <a:xfrm>
-            <a:off x="838688" y="4249400"/>
+            <a:off x="838688" y="1871960"/>
             <a:ext cx="389169" cy="389169"/>
           </a:xfrm>
           <a:prstGeom prst="rect">
@@ -5294,13 +4764,13 @@
       </p:pic>
       <p:sp>
         <p:nvSpPr>
-          <p:cNvPr id="17" name="Text 12"/>
-          <p:cNvSpPr/>
-          <p:nvPr/>
-        </p:nvSpPr>
-        <p:spPr>
-          <a:xfrm>
-            <a:off x="1508760" y="4041648"/>
+          <p:cNvPr id="7" name="Text 4"/>
+          <p:cNvSpPr/>
+          <p:nvPr/>
+        </p:nvSpPr>
+        <p:spPr>
+          <a:xfrm>
+            <a:off x="1508760" y="1664208"/>
             <a:ext cx="9784080" cy="365760"/>
           </a:xfrm>
           <a:prstGeom prst="rect">
@@ -5313,7 +4783,7 @@
           <a:bodyPr wrap="square" rtlCol="0" anchor="ctr"/>
           <a:lstStyle/>
           <a:p>
-            <a:pPr indent="0" marL="0">
+            <a:pPr marL="0" indent="0">
               <a:buNone/>
             </a:pPr>
             <a:r>
@@ -5325,7 +4795,7 @@
                 <a:ea typeface="Calibri" pitchFamily="34" charset="-122"/>
                 <a:cs typeface="Calibri" pitchFamily="34" charset="-120"/>
               </a:rPr>
-              <a:t>Reading and stress-testing AI-generated code before committing</a:t>
+              <a:t>What vibe coding is, and when it is appropriate</a:t>
             </a:r>
             <a:endParaRPr lang="en-US" sz="1550" dirty="0"/>
           </a:p>
@@ -5333,13 +4803,13 @@
       </p:sp>
       <p:sp>
         <p:nvSpPr>
-          <p:cNvPr id="18" name="Text 13"/>
-          <p:cNvSpPr/>
-          <p:nvPr/>
-        </p:nvSpPr>
-        <p:spPr>
-          <a:xfrm>
-            <a:off x="1508760" y="4389120"/>
+          <p:cNvPr id="8" name="Text 5"/>
+          <p:cNvSpPr/>
+          <p:nvPr/>
+        </p:nvSpPr>
+        <p:spPr>
+          <a:xfrm>
+            <a:off x="1508760" y="2011680"/>
             <a:ext cx="9784080" cy="457200"/>
           </a:xfrm>
           <a:prstGeom prst="rect">
@@ -5352,7 +4822,7 @@
           <a:bodyPr wrap="square" rtlCol="0" anchor="ctr"/>
           <a:lstStyle/>
           <a:p>
-            <a:pPr indent="0" marL="0">
+            <a:pPr marL="0" indent="0">
               <a:buNone/>
             </a:pPr>
             <a:r>
@@ -5364,7 +4834,7 @@
                 <a:ea typeface="Calibri" pitchFamily="34" charset="-122"/>
                 <a:cs typeface="Calibri" pitchFamily="34" charset="-120"/>
               </a:rPr>
-              <a:t>Key skill: collaborating across finance and data science roles on a working prototype</a:t>
+              <a:t>Knowledge &amp; understanding: capabilities and limitations of LLM-assisted development</a:t>
             </a:r>
             <a:endParaRPr lang="en-US" sz="1250" dirty="0"/>
           </a:p>
@@ -5372,13 +4842,13 @@
       </p:sp>
       <p:sp>
         <p:nvSpPr>
-          <p:cNvPr id="19" name="Shape 14"/>
-          <p:cNvSpPr/>
-          <p:nvPr/>
-        </p:nvSpPr>
-        <p:spPr>
-          <a:xfrm>
-            <a:off x="548640" y="5120640"/>
+          <p:cNvPr id="9" name="Shape 6"/>
+          <p:cNvSpPr/>
+          <p:nvPr/>
+        </p:nvSpPr>
+        <p:spPr>
+          <a:xfrm>
+            <a:off x="548640" y="2743200"/>
             <a:ext cx="11064240" cy="1024128"/>
           </a:xfrm>
           <a:prstGeom prst="roundRect">
@@ -5391,7 +4861,7 @@
           </a:solidFill>
           <a:ln/>
           <a:effectLst>
-            <a:outerShdw sx="100000" sy="100000" kx="0" ky="0" algn="bl" rotWithShape="0" blurRad="63500" dist="25400" dir="5400000">
+            <a:outerShdw blurRad="63500" dist="25400" dir="5400000" algn="bl" rotWithShape="0">
               <a:srgbClr val="000000">
                 <a:alpha val="8000"/>
               </a:srgbClr>
@@ -5401,13 +4871,13 @@
       </p:sp>
       <p:sp>
         <p:nvSpPr>
-          <p:cNvPr id="20" name="Shape 15"/>
-          <p:cNvSpPr/>
-          <p:nvPr/>
-        </p:nvSpPr>
-        <p:spPr>
-          <a:xfrm>
-            <a:off x="777240" y="5376672"/>
+          <p:cNvPr id="10" name="Shape 7"/>
+          <p:cNvSpPr/>
+          <p:nvPr/>
+        </p:nvSpPr>
+        <p:spPr>
+          <a:xfrm>
+            <a:off x="777240" y="2999232"/>
             <a:ext cx="512064" cy="512064"/>
           </a:xfrm>
           <a:prstGeom prst="ellipse">
@@ -5421,21 +4891,21 @@
       </p:sp>
       <p:pic>
         <p:nvPicPr>
-          <p:cNvPr id="21" name="Image 3" descr="preencoded.png">    </p:cNvPr>
+          <p:cNvPr id="11" name="Image 1" descr="preencoded.png"/>
           <p:cNvPicPr>
             <a:picLocks noChangeAspect="1"/>
           </p:cNvPicPr>
           <p:nvPr/>
         </p:nvPicPr>
         <p:blipFill>
-          <a:blip r:embed="rId4"/>
+          <a:blip r:embed="rId3"/>
           <a:stretch>
             <a:fillRect/>
           </a:stretch>
         </p:blipFill>
         <p:spPr>
           <a:xfrm>
-            <a:off x="838688" y="5438120"/>
+            <a:off x="838688" y="3060680"/>
             <a:ext cx="389169" cy="389169"/>
           </a:xfrm>
           <a:prstGeom prst="rect">
@@ -5445,13 +4915,13 @@
       </p:pic>
       <p:sp>
         <p:nvSpPr>
-          <p:cNvPr id="22" name="Text 16"/>
-          <p:cNvSpPr/>
-          <p:nvPr/>
-        </p:nvSpPr>
-        <p:spPr>
-          <a:xfrm>
-            <a:off x="1508760" y="5230368"/>
+          <p:cNvPr id="12" name="Text 8"/>
+          <p:cNvSpPr/>
+          <p:nvPr/>
+        </p:nvSpPr>
+        <p:spPr>
+          <a:xfrm>
+            <a:off x="1508760" y="2852928"/>
             <a:ext cx="9784080" cy="365760"/>
           </a:xfrm>
           <a:prstGeom prst="rect">
@@ -5464,7 +4934,7 @@
           <a:bodyPr wrap="square" rtlCol="0" anchor="ctr"/>
           <a:lstStyle/>
           <a:p>
-            <a:pPr indent="0" marL="0">
+            <a:pPr marL="0" indent="0">
               <a:buNone/>
             </a:pPr>
             <a:r>
@@ -5476,6 +4946,308 @@
                 <a:ea typeface="Calibri" pitchFamily="34" charset="-122"/>
                 <a:cs typeface="Calibri" pitchFamily="34" charset="-120"/>
               </a:rPr>
+              <a:t>The describe → generate → review → refine workflow</a:t>
+            </a:r>
+            <a:endParaRPr lang="en-US" sz="1550" dirty="0"/>
+          </a:p>
+        </p:txBody>
+      </p:sp>
+      <p:sp>
+        <p:nvSpPr>
+          <p:cNvPr id="13" name="Text 9"/>
+          <p:cNvSpPr/>
+          <p:nvPr/>
+        </p:nvSpPr>
+        <p:spPr>
+          <a:xfrm>
+            <a:off x="1508760" y="3200400"/>
+            <a:ext cx="9784080" cy="457200"/>
+          </a:xfrm>
+          <a:prstGeom prst="rect">
+            <a:avLst/>
+          </a:prstGeom>
+          <a:noFill/>
+          <a:ln/>
+        </p:spPr>
+        <p:txBody>
+          <a:bodyPr wrap="square" rtlCol="0" anchor="ctr"/>
+          <a:lstStyle/>
+          <a:p>
+            <a:pPr marL="0" indent="0">
+              <a:buNone/>
+            </a:pPr>
+            <a:r>
+              <a:rPr lang="en-US" sz="1250" dirty="0">
+                <a:solidFill>
+                  <a:srgbClr val="3A3F4B"/>
+                </a:solidFill>
+                <a:latin typeface="Calibri" pitchFamily="34" charset="0"/>
+                <a:ea typeface="Calibri" pitchFamily="34" charset="-122"/>
+                <a:cs typeface="Calibri" pitchFamily="34" charset="-120"/>
+              </a:rPr>
+              <a:t>Cognitive skill: translating an investment thesis into functional requirements a model can act on</a:t>
+            </a:r>
+            <a:endParaRPr lang="en-US" sz="1250" dirty="0"/>
+          </a:p>
+        </p:txBody>
+      </p:sp>
+      <p:sp>
+        <p:nvSpPr>
+          <p:cNvPr id="14" name="Shape 10"/>
+          <p:cNvSpPr/>
+          <p:nvPr/>
+        </p:nvSpPr>
+        <p:spPr>
+          <a:xfrm>
+            <a:off x="548640" y="3931920"/>
+            <a:ext cx="11064240" cy="1024128"/>
+          </a:xfrm>
+          <a:prstGeom prst="roundRect">
+            <a:avLst>
+              <a:gd name="adj" fmla="val 5357"/>
+            </a:avLst>
+          </a:prstGeom>
+          <a:solidFill>
+            <a:srgbClr val="FFFFFF"/>
+          </a:solidFill>
+          <a:ln/>
+          <a:effectLst>
+            <a:outerShdw blurRad="63500" dist="25400" dir="5400000" algn="bl" rotWithShape="0">
+              <a:srgbClr val="000000">
+                <a:alpha val="8000"/>
+              </a:srgbClr>
+            </a:outerShdw>
+          </a:effectLst>
+        </p:spPr>
+      </p:sp>
+      <p:sp>
+        <p:nvSpPr>
+          <p:cNvPr id="15" name="Shape 11"/>
+          <p:cNvSpPr/>
+          <p:nvPr/>
+        </p:nvSpPr>
+        <p:spPr>
+          <a:xfrm>
+            <a:off x="777240" y="4187952"/>
+            <a:ext cx="512064" cy="512064"/>
+          </a:xfrm>
+          <a:prstGeom prst="ellipse">
+            <a:avLst/>
+          </a:prstGeom>
+          <a:solidFill>
+            <a:srgbClr val="F1EEE3"/>
+          </a:solidFill>
+          <a:ln/>
+        </p:spPr>
+      </p:sp>
+      <p:pic>
+        <p:nvPicPr>
+          <p:cNvPr id="16" name="Image 2" descr="preencoded.png"/>
+          <p:cNvPicPr>
+            <a:picLocks noChangeAspect="1"/>
+          </p:cNvPicPr>
+          <p:nvPr/>
+        </p:nvPicPr>
+        <p:blipFill>
+          <a:blip r:embed="rId3"/>
+          <a:stretch>
+            <a:fillRect/>
+          </a:stretch>
+        </p:blipFill>
+        <p:spPr>
+          <a:xfrm>
+            <a:off x="838688" y="4249400"/>
+            <a:ext cx="389169" cy="389169"/>
+          </a:xfrm>
+          <a:prstGeom prst="rect">
+            <a:avLst/>
+          </a:prstGeom>
+        </p:spPr>
+      </p:pic>
+      <p:sp>
+        <p:nvSpPr>
+          <p:cNvPr id="17" name="Text 12"/>
+          <p:cNvSpPr/>
+          <p:nvPr/>
+        </p:nvSpPr>
+        <p:spPr>
+          <a:xfrm>
+            <a:off x="1508760" y="4041648"/>
+            <a:ext cx="9784080" cy="365760"/>
+          </a:xfrm>
+          <a:prstGeom prst="rect">
+            <a:avLst/>
+          </a:prstGeom>
+          <a:noFill/>
+          <a:ln/>
+        </p:spPr>
+        <p:txBody>
+          <a:bodyPr wrap="square" rtlCol="0" anchor="ctr"/>
+          <a:lstStyle/>
+          <a:p>
+            <a:pPr marL="0" indent="0">
+              <a:buNone/>
+            </a:pPr>
+            <a:r>
+              <a:rPr lang="en-US" sz="1550" b="1" dirty="0">
+                <a:solidFill>
+                  <a:srgbClr val="14213D"/>
+                </a:solidFill>
+                <a:latin typeface="Calibri" pitchFamily="34" charset="0"/>
+                <a:ea typeface="Calibri" pitchFamily="34" charset="-122"/>
+                <a:cs typeface="Calibri" pitchFamily="34" charset="-120"/>
+              </a:rPr>
+              <a:t>Reading and stress-testing AI-generated code before committing</a:t>
+            </a:r>
+            <a:endParaRPr lang="en-US" sz="1550" dirty="0"/>
+          </a:p>
+        </p:txBody>
+      </p:sp>
+      <p:sp>
+        <p:nvSpPr>
+          <p:cNvPr id="18" name="Text 13"/>
+          <p:cNvSpPr/>
+          <p:nvPr/>
+        </p:nvSpPr>
+        <p:spPr>
+          <a:xfrm>
+            <a:off x="1508760" y="4389120"/>
+            <a:ext cx="9784080" cy="457200"/>
+          </a:xfrm>
+          <a:prstGeom prst="rect">
+            <a:avLst/>
+          </a:prstGeom>
+          <a:noFill/>
+          <a:ln/>
+        </p:spPr>
+        <p:txBody>
+          <a:bodyPr wrap="square" rtlCol="0" anchor="ctr"/>
+          <a:lstStyle/>
+          <a:p>
+            <a:pPr marL="0" indent="0">
+              <a:buNone/>
+            </a:pPr>
+            <a:r>
+              <a:rPr lang="en-US" sz="1250" dirty="0">
+                <a:solidFill>
+                  <a:srgbClr val="3A3F4B"/>
+                </a:solidFill>
+                <a:latin typeface="Calibri" pitchFamily="34" charset="0"/>
+                <a:ea typeface="Calibri" pitchFamily="34" charset="-122"/>
+                <a:cs typeface="Calibri" pitchFamily="34" charset="-120"/>
+              </a:rPr>
+              <a:t>Key skill: collaborating across finance and data science roles on a working prototype</a:t>
+            </a:r>
+            <a:endParaRPr lang="en-US" sz="1250" dirty="0"/>
+          </a:p>
+        </p:txBody>
+      </p:sp>
+      <p:sp>
+        <p:nvSpPr>
+          <p:cNvPr id="19" name="Shape 14"/>
+          <p:cNvSpPr/>
+          <p:nvPr/>
+        </p:nvSpPr>
+        <p:spPr>
+          <a:xfrm>
+            <a:off x="548640" y="5120640"/>
+            <a:ext cx="11064240" cy="1024128"/>
+          </a:xfrm>
+          <a:prstGeom prst="roundRect">
+            <a:avLst>
+              <a:gd name="adj" fmla="val 5357"/>
+            </a:avLst>
+          </a:prstGeom>
+          <a:solidFill>
+            <a:srgbClr val="FFFFFF"/>
+          </a:solidFill>
+          <a:ln/>
+          <a:effectLst>
+            <a:outerShdw blurRad="63500" dist="25400" dir="5400000" algn="bl" rotWithShape="0">
+              <a:srgbClr val="000000">
+                <a:alpha val="8000"/>
+              </a:srgbClr>
+            </a:outerShdw>
+          </a:effectLst>
+        </p:spPr>
+      </p:sp>
+      <p:sp>
+        <p:nvSpPr>
+          <p:cNvPr id="20" name="Shape 15"/>
+          <p:cNvSpPr/>
+          <p:nvPr/>
+        </p:nvSpPr>
+        <p:spPr>
+          <a:xfrm>
+            <a:off x="777240" y="5376672"/>
+            <a:ext cx="512064" cy="512064"/>
+          </a:xfrm>
+          <a:prstGeom prst="ellipse">
+            <a:avLst/>
+          </a:prstGeom>
+          <a:solidFill>
+            <a:srgbClr val="F1EEE3"/>
+          </a:solidFill>
+          <a:ln/>
+        </p:spPr>
+      </p:sp>
+      <p:pic>
+        <p:nvPicPr>
+          <p:cNvPr id="21" name="Image 3" descr="preencoded.png"/>
+          <p:cNvPicPr>
+            <a:picLocks noChangeAspect="1"/>
+          </p:cNvPicPr>
+          <p:nvPr/>
+        </p:nvPicPr>
+        <p:blipFill>
+          <a:blip r:embed="rId3"/>
+          <a:stretch>
+            <a:fillRect/>
+          </a:stretch>
+        </p:blipFill>
+        <p:spPr>
+          <a:xfrm>
+            <a:off x="838688" y="5438120"/>
+            <a:ext cx="389169" cy="389169"/>
+          </a:xfrm>
+          <a:prstGeom prst="rect">
+            <a:avLst/>
+          </a:prstGeom>
+        </p:spPr>
+      </p:pic>
+      <p:sp>
+        <p:nvSpPr>
+          <p:cNvPr id="22" name="Text 16"/>
+          <p:cNvSpPr/>
+          <p:nvPr/>
+        </p:nvSpPr>
+        <p:spPr>
+          <a:xfrm>
+            <a:off x="1508760" y="5230368"/>
+            <a:ext cx="9784080" cy="365760"/>
+          </a:xfrm>
+          <a:prstGeom prst="rect">
+            <a:avLst/>
+          </a:prstGeom>
+          <a:noFill/>
+          <a:ln/>
+        </p:spPr>
+        <p:txBody>
+          <a:bodyPr wrap="square" rtlCol="0" anchor="ctr"/>
+          <a:lstStyle/>
+          <a:p>
+            <a:pPr marL="0" indent="0">
+              <a:buNone/>
+            </a:pPr>
+            <a:r>
+              <a:rPr lang="en-US" sz="1550" b="1" dirty="0">
+                <a:solidFill>
+                  <a:srgbClr val="14213D"/>
+                </a:solidFill>
+                <a:latin typeface="Calibri" pitchFamily="34" charset="0"/>
+                <a:ea typeface="Calibri" pitchFamily="34" charset="-122"/>
+                <a:cs typeface="Calibri" pitchFamily="34" charset="-120"/>
+              </a:rPr>
               <a:t>Recognizing common AI failure modes early</a:t>
             </a:r>
             <a:endParaRPr lang="en-US" sz="1550" dirty="0"/>
@@ -5503,7 +5275,7 @@
           <a:bodyPr wrap="square" rtlCol="0" anchor="ctr"/>
           <a:lstStyle/>
           <a:p>
-            <a:pPr indent="0" marL="0">
+            <a:pPr marL="0" indent="0">
               <a:buNone/>
             </a:pPr>
             <a:r>
@@ -5537,6 +5309,7 @@
         <a:solidFill>
           <a:srgbClr val="14213D"/>
         </a:solidFill>
+        <a:effectLst/>
       </p:bgPr>
     </p:bg>
     <p:spTree>
@@ -5575,14 +5348,14 @@
       </p:sp>
       <p:pic>
         <p:nvPicPr>
-          <p:cNvPr id="3" name="Image 0" descr="preencoded.png">    </p:cNvPr>
+          <p:cNvPr id="3" name="Image 0" descr="preencoded.png"/>
           <p:cNvPicPr>
             <a:picLocks noChangeAspect="1"/>
           </p:cNvPicPr>
           <p:nvPr/>
         </p:nvPicPr>
         <p:blipFill>
-          <a:blip r:embed="rId1"/>
+          <a:blip r:embed="rId3"/>
           <a:stretch>
             <a:fillRect/>
           </a:stretch>
@@ -5618,7 +5391,7 @@
           <a:bodyPr wrap="square" rtlCol="0" anchor="ctr"/>
           <a:lstStyle/>
           <a:p>
-            <a:pPr indent="0" marL="0">
+            <a:pPr marL="0" indent="0">
               <a:buNone/>
             </a:pPr>
             <a:r>
@@ -5657,7 +5430,7 @@
           <a:bodyPr wrap="square" rtlCol="0" anchor="ctr"/>
           <a:lstStyle/>
           <a:p>
-            <a:pPr indent="0" marL="0">
+            <a:pPr marL="0" indent="0">
               <a:buNone/>
             </a:pPr>
             <a:r>
@@ -5716,7 +5489,7 @@
           <a:bodyPr wrap="square" rtlCol="0" anchor="ctr"/>
           <a:lstStyle/>
           <a:p>
-            <a:pPr indent="0" marL="0">
+            <a:pPr marL="0" indent="0">
               <a:buNone/>
             </a:pPr>
             <a:r>
@@ -5775,7 +5548,7 @@
           <a:bodyPr wrap="square" rtlCol="0" anchor="ctr"/>
           <a:lstStyle/>
           <a:p>
-            <a:pPr indent="0" marL="0">
+            <a:pPr marL="0" indent="0">
               <a:buNone/>
             </a:pPr>
             <a:r>
@@ -5834,7 +5607,7 @@
           <a:bodyPr wrap="square" rtlCol="0" anchor="ctr"/>
           <a:lstStyle/>
           <a:p>
-            <a:pPr indent="0" marL="0">
+            <a:pPr marL="0" indent="0">
               <a:buNone/>
             </a:pPr>
             <a:r>
@@ -5873,7 +5646,7 @@
           <a:bodyPr wrap="square" rtlCol="0" anchor="ctr"/>
           <a:lstStyle/>
           <a:p>
-            <a:pPr indent="0" marL="0">
+            <a:pPr marL="0" indent="0">
               <a:buNone/>
             </a:pPr>
             <a:r>
@@ -5912,7 +5685,7 @@
           <a:bodyPr wrap="square" rtlCol="0" anchor="ctr"/>
           <a:lstStyle/>
           <a:p>
-            <a:pPr indent="0" marL="0">
+            <a:pPr marL="0" indent="0">
               <a:buNone/>
             </a:pPr>
             <a:r>
@@ -5946,6 +5719,7 @@
         <a:solidFill>
           <a:srgbClr val="FAFAF7"/>
         </a:solidFill>
+        <a:effectLst/>
       </p:bgPr>
     </p:bg>
     <p:spTree>
@@ -5964,6 +5738,34 @@
       </p:grpSpPr>
       <p:sp>
         <p:nvSpPr>
+          <p:cNvPr id="18" name="Shape 3">
+            <a:extLst>
+              <a:ext uri="{FF2B5EF4-FFF2-40B4-BE49-F238E27FC236}">
+                <a16:creationId xmlns:a16="http://schemas.microsoft.com/office/drawing/2014/main" id="{13C285A3-9D51-BABD-2230-D7D33C73BC76}"/>
+              </a:ext>
+            </a:extLst>
+          </p:cNvPr>
+          <p:cNvSpPr/>
+          <p:nvPr/>
+        </p:nvSpPr>
+        <p:spPr>
+          <a:xfrm>
+            <a:off x="636741" y="5349240"/>
+            <a:ext cx="11064240" cy="457200"/>
+          </a:xfrm>
+          <a:prstGeom prst="roundRect">
+            <a:avLst>
+              <a:gd name="adj" fmla="val 5000"/>
+            </a:avLst>
+          </a:prstGeom>
+          <a:solidFill>
+            <a:srgbClr val="14213D"/>
+          </a:solidFill>
+          <a:ln/>
+        </p:spPr>
+      </p:sp>
+      <p:sp>
+        <p:nvSpPr>
           <p:cNvPr id="2" name="Text 0"/>
           <p:cNvSpPr/>
           <p:nvPr/>
@@ -5983,7 +5785,7 @@
           <a:bodyPr wrap="square" rtlCol="0" anchor="ctr"/>
           <a:lstStyle/>
           <a:p>
-            <a:pPr indent="0" marL="0">
+            <a:pPr marL="0" indent="0">
               <a:buNone/>
             </a:pPr>
             <a:r>
@@ -6022,7 +5824,7 @@
           <a:bodyPr wrap="square" rtlCol="0" anchor="ctr"/>
           <a:lstStyle/>
           <a:p>
-            <a:pPr indent="0" marL="0">
+            <a:pPr marL="0" indent="0">
               <a:buNone/>
             </a:pPr>
             <a:r>
@@ -6061,7 +5863,7 @@
           </a:solidFill>
           <a:ln/>
           <a:effectLst>
-            <a:outerShdw sx="100000" sy="100000" kx="0" ky="0" algn="bl" rotWithShape="0" blurRad="76200" dist="25400" dir="5400000">
+            <a:outerShdw blurRad="76200" dist="25400" dir="5400000" algn="bl" rotWithShape="0">
               <a:srgbClr val="000000">
                 <a:alpha val="10000"/>
               </a:srgbClr>
@@ -6090,7 +5892,7 @@
           <a:bodyPr wrap="square" rtlCol="0" anchor="ctr"/>
           <a:lstStyle/>
           <a:p>
-            <a:pPr algn="ctr" indent="0" marL="0">
+            <a:pPr marL="0" indent="0" algn="ctr">
               <a:buNone/>
             </a:pPr>
             <a:r>
@@ -6129,7 +5931,7 @@
           <a:bodyPr wrap="square" rtlCol="0" anchor="ctr"/>
           <a:lstStyle/>
           <a:p>
-            <a:pPr algn="ctr" indent="0" marL="0">
+            <a:pPr marL="0" indent="0" algn="ctr">
               <a:buNone/>
             </a:pPr>
             <a:r>
@@ -6168,7 +5970,7 @@
           </a:solidFill>
           <a:ln/>
           <a:effectLst>
-            <a:outerShdw sx="100000" sy="100000" kx="0" ky="0" algn="bl" rotWithShape="0" blurRad="76200" dist="25400" dir="5400000">
+            <a:outerShdw blurRad="76200" dist="25400" dir="5400000" algn="bl" rotWithShape="0">
               <a:srgbClr val="000000">
                 <a:alpha val="10000"/>
               </a:srgbClr>
@@ -6197,7 +5999,7 @@
           <a:bodyPr wrap="square" rtlCol="0" anchor="ctr"/>
           <a:lstStyle/>
           <a:p>
-            <a:pPr algn="ctr" indent="0" marL="0">
+            <a:pPr marL="0" indent="0" algn="ctr">
               <a:buNone/>
             </a:pPr>
             <a:r>
@@ -6236,7 +6038,7 @@
           <a:bodyPr wrap="square" rtlCol="0" anchor="ctr"/>
           <a:lstStyle/>
           <a:p>
-            <a:pPr algn="ctr" indent="0" marL="0">
+            <a:pPr marL="0" indent="0" algn="ctr">
               <a:buNone/>
             </a:pPr>
             <a:r>
@@ -6275,7 +6077,7 @@
           </a:solidFill>
           <a:ln/>
           <a:effectLst>
-            <a:outerShdw sx="100000" sy="100000" kx="0" ky="0" algn="bl" rotWithShape="0" blurRad="76200" dist="25400" dir="5400000">
+            <a:outerShdw blurRad="76200" dist="25400" dir="5400000" algn="bl" rotWithShape="0">
               <a:srgbClr val="000000">
                 <a:alpha val="10000"/>
               </a:srgbClr>
@@ -6304,7 +6106,7 @@
           <a:bodyPr wrap="square" rtlCol="0" anchor="ctr"/>
           <a:lstStyle/>
           <a:p>
-            <a:pPr algn="ctr" indent="0" marL="0">
+            <a:pPr marL="0" indent="0" algn="ctr">
               <a:buNone/>
             </a:pPr>
             <a:r>
@@ -6343,7 +6145,7 @@
           <a:bodyPr wrap="square" rtlCol="0" anchor="ctr"/>
           <a:lstStyle/>
           <a:p>
-            <a:pPr algn="ctr" indent="0" marL="0">
+            <a:pPr marL="0" indent="0" algn="ctr">
               <a:buNone/>
             </a:pPr>
             <a:r>
@@ -6382,7 +6184,7 @@
           </a:solidFill>
           <a:ln/>
           <a:effectLst>
-            <a:outerShdw sx="100000" sy="100000" kx="0" ky="0" algn="bl" rotWithShape="0" blurRad="76200" dist="25400" dir="5400000">
+            <a:outerShdw blurRad="76200" dist="25400" dir="5400000" algn="bl" rotWithShape="0">
               <a:srgbClr val="000000">
                 <a:alpha val="10000"/>
               </a:srgbClr>
@@ -6411,7 +6213,7 @@
           <a:bodyPr wrap="square" rtlCol="0" anchor="ctr"/>
           <a:lstStyle/>
           <a:p>
-            <a:pPr algn="ctr" indent="0" marL="0">
+            <a:pPr marL="0" indent="0" algn="ctr">
               <a:buNone/>
             </a:pPr>
             <a:r>
@@ -6450,7 +6252,7 @@
           <a:bodyPr wrap="square" rtlCol="0" anchor="ctr"/>
           <a:lstStyle/>
           <a:p>
-            <a:pPr algn="ctr" indent="0" marL="0">
+            <a:pPr marL="0" indent="0" algn="ctr">
               <a:buNone/>
             </a:pPr>
             <a:r>
@@ -6489,7 +6291,7 @@
           <a:bodyPr wrap="square" rtlCol="0" anchor="ctr"/>
           <a:lstStyle/>
           <a:p>
-            <a:pPr indent="0" marL="0">
+            <a:pPr marL="0" indent="0">
               <a:buNone/>
             </a:pPr>
             <a:r>
@@ -6504,6 +6306,46 @@
               <a:t>Sources: Keyhole Software 2026 Vibe Coding Trends report; daily.dev, Vibe Coding Explained (2026), aggregating GitHub Octoverse, Stack Overflow, and Gartner data.</a:t>
             </a:r>
             <a:endParaRPr lang="en-US" sz="1000" dirty="0"/>
+          </a:p>
+        </p:txBody>
+      </p:sp>
+      <p:sp>
+        <p:nvSpPr>
+          <p:cNvPr id="17" name="TextBox 16">
+            <a:extLst>
+              <a:ext uri="{FF2B5EF4-FFF2-40B4-BE49-F238E27FC236}">
+                <a16:creationId xmlns:a16="http://schemas.microsoft.com/office/drawing/2014/main" id="{CBC06887-E526-DD75-AEDC-4527B3173260}"/>
+              </a:ext>
+            </a:extLst>
+          </p:cNvPr>
+          <p:cNvSpPr txBox="1"/>
+          <p:nvPr/>
+        </p:nvSpPr>
+        <p:spPr>
+          <a:xfrm>
+            <a:off x="1982142" y="5393174"/>
+            <a:ext cx="8373438" cy="369332"/>
+          </a:xfrm>
+          <a:prstGeom prst="rect">
+            <a:avLst/>
+          </a:prstGeom>
+          <a:noFill/>
+        </p:spPr>
+        <p:txBody>
+          <a:bodyPr wrap="square" rtlCol="0">
+            <a:spAutoFit/>
+          </a:bodyPr>
+          <a:lstStyle/>
+          <a:p>
+            <a:pPr algn="ctr"/>
+            <a:r>
+              <a:rPr lang="en-US" dirty="0">
+                <a:solidFill>
+                  <a:schemeClr val="bg1"/>
+                </a:solidFill>
+              </a:rPr>
+              <a:t>Vibe coding decouples execution from expertise. </a:t>
+            </a:r>
           </a:p>
         </p:txBody>
       </p:sp>
@@ -6523,6 +6365,7 @@
         <a:solidFill>
           <a:srgbClr val="FAFAF7"/>
         </a:solidFill>
+        <a:effectLst/>
       </p:bgPr>
     </p:bg>
     <p:spTree>
@@ -6560,7 +6403,7 @@
           <a:bodyPr wrap="square" rtlCol="0" anchor="ctr"/>
           <a:lstStyle/>
           <a:p>
-            <a:pPr indent="0" marL="0">
+            <a:pPr marL="0" indent="0">
               <a:buNone/>
             </a:pPr>
             <a:r>
@@ -6599,7 +6442,7 @@
           </a:solidFill>
           <a:ln/>
           <a:effectLst>
-            <a:outerShdw sx="100000" sy="100000" kx="0" ky="0" algn="bl" rotWithShape="0" blurRad="76200" dist="25400" dir="5400000">
+            <a:outerShdw blurRad="76200" dist="25400" dir="5400000" algn="bl" rotWithShape="0">
               <a:srgbClr val="000000">
                 <a:alpha val="8000"/>
               </a:srgbClr>
@@ -6629,14 +6472,14 @@
       </p:sp>
       <p:pic>
         <p:nvPicPr>
-          <p:cNvPr id="5" name="Image 0" descr="preencoded.png">    </p:cNvPr>
+          <p:cNvPr id="5" name="Image 0" descr="preencoded.png"/>
           <p:cNvPicPr>
             <a:picLocks noChangeAspect="1"/>
           </p:cNvPicPr>
           <p:nvPr/>
         </p:nvPicPr>
         <p:blipFill>
-          <a:blip r:embed="rId1"/>
+          <a:blip r:embed="rId3"/>
           <a:stretch>
             <a:fillRect/>
           </a:stretch>
@@ -6672,7 +6515,7 @@
           <a:bodyPr wrap="square" rtlCol="0" anchor="ctr"/>
           <a:lstStyle/>
           <a:p>
-            <a:pPr indent="0" marL="0">
+            <a:pPr marL="0" indent="0">
               <a:buNone/>
             </a:pPr>
             <a:r>
@@ -6894,14 +6737,14 @@
       </p:sp>
       <p:pic>
         <p:nvPicPr>
-          <p:cNvPr id="13" name="Image 1" descr="preencoded.png">    </p:cNvPr>
+          <p:cNvPr id="13" name="Image 1" descr="preencoded.png"/>
           <p:cNvPicPr>
             <a:picLocks noChangeAspect="1"/>
           </p:cNvPicPr>
           <p:nvPr/>
         </p:nvPicPr>
         <p:blipFill>
-          <a:blip r:embed="rId2"/>
+          <a:blip r:embed="rId4"/>
           <a:stretch>
             <a:fillRect/>
           </a:stretch>
@@ -6937,7 +6780,7 @@
           <a:bodyPr wrap="square" rtlCol="0" anchor="ctr"/>
           <a:lstStyle/>
           <a:p>
-            <a:pPr indent="0" marL="0">
+            <a:pPr marL="0" indent="0">
               <a:buNone/>
             </a:pPr>
             <a:r>
@@ -7131,6 +6974,7 @@
         <a:solidFill>
           <a:srgbClr val="FAFAF7"/>
         </a:solidFill>
+        <a:effectLst/>
       </p:bgPr>
     </p:bg>
     <p:spTree>
@@ -7168,7 +7012,7 @@
           <a:bodyPr wrap="square" rtlCol="0" anchor="ctr"/>
           <a:lstStyle/>
           <a:p>
-            <a:pPr indent="0" marL="0">
+            <a:pPr marL="0" indent="0">
               <a:buNone/>
             </a:pPr>
             <a:r>
@@ -7207,7 +7051,7 @@
           </a:solidFill>
           <a:ln/>
           <a:effectLst>
-            <a:outerShdw sx="100000" sy="100000" kx="0" ky="0" algn="bl" rotWithShape="0" blurRad="76200" dist="25400" dir="5400000">
+            <a:outerShdw blurRad="76200" dist="25400" dir="5400000" algn="bl" rotWithShape="0">
               <a:srgbClr val="000000">
                 <a:alpha val="8000"/>
               </a:srgbClr>
@@ -7256,7 +7100,7 @@
           <a:bodyPr wrap="square" rtlCol="0" anchor="ctr"/>
           <a:lstStyle/>
           <a:p>
-            <a:pPr algn="ctr" indent="0" marL="0">
+            <a:pPr marL="0" indent="0" algn="ctr">
               <a:buNone/>
             </a:pPr>
             <a:r>
@@ -7295,7 +7139,7 @@
           <a:bodyPr wrap="square" rtlCol="0" anchor="ctr"/>
           <a:lstStyle/>
           <a:p>
-            <a:pPr indent="0" marL="0">
+            <a:pPr marL="0" indent="0">
               <a:buNone/>
             </a:pPr>
             <a:r>
@@ -7334,7 +7178,7 @@
           <a:bodyPr wrap="square" rtlCol="0" anchor="ctr"/>
           <a:lstStyle/>
           <a:p>
-            <a:pPr indent="0" marL="0">
+            <a:pPr marL="0" indent="0">
               <a:buNone/>
             </a:pPr>
             <a:r>
@@ -7373,7 +7217,7 @@
           <a:bodyPr wrap="square" rtlCol="0" anchor="ctr"/>
           <a:lstStyle/>
           <a:p>
-            <a:pPr algn="ctr" indent="0" marL="0">
+            <a:pPr marL="0" indent="0" algn="ctr">
               <a:buNone/>
             </a:pPr>
             <a:r>
@@ -7412,7 +7256,7 @@
           </a:solidFill>
           <a:ln/>
           <a:effectLst>
-            <a:outerShdw sx="100000" sy="100000" kx="0" ky="0" algn="bl" rotWithShape="0" blurRad="76200" dist="25400" dir="5400000">
+            <a:outerShdw blurRad="76200" dist="25400" dir="5400000" algn="bl" rotWithShape="0">
               <a:srgbClr val="000000">
                 <a:alpha val="8000"/>
               </a:srgbClr>
@@ -7461,7 +7305,7 @@
           <a:bodyPr wrap="square" rtlCol="0" anchor="ctr"/>
           <a:lstStyle/>
           <a:p>
-            <a:pPr algn="ctr" indent="0" marL="0">
+            <a:pPr marL="0" indent="0" algn="ctr">
               <a:buNone/>
             </a:pPr>
             <a:r>
@@ -7500,7 +7344,7 @@
           <a:bodyPr wrap="square" rtlCol="0" anchor="ctr"/>
           <a:lstStyle/>
           <a:p>
-            <a:pPr indent="0" marL="0">
+            <a:pPr marL="0" indent="0">
               <a:buNone/>
             </a:pPr>
             <a:r>
@@ -7539,7 +7383,7 @@
           <a:bodyPr wrap="square" rtlCol="0" anchor="ctr"/>
           <a:lstStyle/>
           <a:p>
-            <a:pPr indent="0" marL="0">
+            <a:pPr marL="0" indent="0">
               <a:buNone/>
             </a:pPr>
             <a:r>
@@ -7578,7 +7422,7 @@
           <a:bodyPr wrap="square" rtlCol="0" anchor="ctr"/>
           <a:lstStyle/>
           <a:p>
-            <a:pPr algn="ctr" indent="0" marL="0">
+            <a:pPr marL="0" indent="0" algn="ctr">
               <a:buNone/>
             </a:pPr>
             <a:r>
@@ -7617,7 +7461,7 @@
           </a:solidFill>
           <a:ln/>
           <a:effectLst>
-            <a:outerShdw sx="100000" sy="100000" kx="0" ky="0" algn="bl" rotWithShape="0" blurRad="76200" dist="25400" dir="5400000">
+            <a:outerShdw blurRad="76200" dist="25400" dir="5400000" algn="bl" rotWithShape="0">
               <a:srgbClr val="000000">
                 <a:alpha val="8000"/>
               </a:srgbClr>
@@ -7666,7 +7510,7 @@
           <a:bodyPr wrap="square" rtlCol="0" anchor="ctr"/>
           <a:lstStyle/>
           <a:p>
-            <a:pPr algn="ctr" indent="0" marL="0">
+            <a:pPr marL="0" indent="0" algn="ctr">
               <a:buNone/>
             </a:pPr>
             <a:r>
@@ -7705,7 +7549,7 @@
           <a:bodyPr wrap="square" rtlCol="0" anchor="ctr"/>
           <a:lstStyle/>
           <a:p>
-            <a:pPr indent="0" marL="0">
+            <a:pPr marL="0" indent="0">
               <a:buNone/>
             </a:pPr>
             <a:r>
@@ -7744,7 +7588,7 @@
           <a:bodyPr wrap="square" rtlCol="0" anchor="ctr"/>
           <a:lstStyle/>
           <a:p>
-            <a:pPr indent="0" marL="0">
+            <a:pPr marL="0" indent="0">
               <a:buNone/>
             </a:pPr>
             <a:r>
@@ -7783,7 +7627,7 @@
           <a:bodyPr wrap="square" rtlCol="0" anchor="ctr"/>
           <a:lstStyle/>
           <a:p>
-            <a:pPr algn="ctr" indent="0" marL="0">
+            <a:pPr marL="0" indent="0" algn="ctr">
               <a:buNone/>
             </a:pPr>
             <a:r>
@@ -7822,7 +7666,7 @@
           </a:solidFill>
           <a:ln/>
           <a:effectLst>
-            <a:outerShdw sx="100000" sy="100000" kx="0" ky="0" algn="bl" rotWithShape="0" blurRad="76200" dist="25400" dir="5400000">
+            <a:outerShdw blurRad="76200" dist="25400" dir="5400000" algn="bl" rotWithShape="0">
               <a:srgbClr val="000000">
                 <a:alpha val="8000"/>
               </a:srgbClr>
@@ -7871,7 +7715,7 @@
           <a:bodyPr wrap="square" rtlCol="0" anchor="ctr"/>
           <a:lstStyle/>
           <a:p>
-            <a:pPr algn="ctr" indent="0" marL="0">
+            <a:pPr marL="0" indent="0" algn="ctr">
               <a:buNone/>
             </a:pPr>
             <a:r>
@@ -7910,7 +7754,7 @@
           <a:bodyPr wrap="square" rtlCol="0" anchor="ctr"/>
           <a:lstStyle/>
           <a:p>
-            <a:pPr indent="0" marL="0">
+            <a:pPr marL="0" indent="0">
               <a:buNone/>
             </a:pPr>
             <a:r>
@@ -7949,7 +7793,7 @@
           <a:bodyPr wrap="square" rtlCol="0" anchor="ctr"/>
           <a:lstStyle/>
           <a:p>
-            <a:pPr indent="0" marL="0">
+            <a:pPr marL="0" indent="0">
               <a:buNone/>
             </a:pPr>
             <a:r>
@@ -7988,7 +7832,7 @@
           <a:bodyPr wrap="square" rtlCol="0" anchor="ctr"/>
           <a:lstStyle/>
           <a:p>
-            <a:pPr indent="0" marL="0">
+            <a:pPr marL="0" indent="0">
               <a:buNone/>
             </a:pPr>
             <a:r>
@@ -8022,6 +7866,7 @@
         <a:solidFill>
           <a:srgbClr val="14213D"/>
         </a:solidFill>
+        <a:effectLst/>
       </p:bgPr>
     </p:bg>
     <p:spTree>
@@ -8060,14 +7905,14 @@
       </p:sp>
       <p:pic>
         <p:nvPicPr>
-          <p:cNvPr id="3" name="Image 0" descr="preencoded.png">    </p:cNvPr>
+          <p:cNvPr id="3" name="Image 0" descr="preencoded.png"/>
           <p:cNvPicPr>
             <a:picLocks noChangeAspect="1"/>
           </p:cNvPicPr>
           <p:nvPr/>
         </p:nvPicPr>
         <p:blipFill>
-          <a:blip r:embed="rId1"/>
+          <a:blip r:embed="rId3"/>
           <a:stretch>
             <a:fillRect/>
           </a:stretch>
@@ -8103,7 +7948,7 @@
           <a:bodyPr wrap="square" rtlCol="0" anchor="ctr"/>
           <a:lstStyle/>
           <a:p>
-            <a:pPr indent="0" marL="0">
+            <a:pPr marL="0" indent="0">
               <a:buNone/>
             </a:pPr>
             <a:r>
@@ -8142,7 +7987,7 @@
           <a:bodyPr wrap="square" rtlCol="0" anchor="ctr"/>
           <a:lstStyle/>
           <a:p>
-            <a:pPr indent="0" marL="0">
+            <a:pPr marL="0" indent="0">
               <a:buNone/>
             </a:pPr>
             <a:r>
@@ -8203,7 +8048,7 @@
           <a:bodyPr wrap="square" rtlCol="0" anchor="ctr"/>
           <a:lstStyle/>
           <a:p>
-            <a:pPr indent="0" marL="0">
+            <a:pPr marL="0" indent="0">
               <a:buNone/>
             </a:pPr>
             <a:r>
@@ -8242,7 +8087,7 @@
           <a:bodyPr wrap="square" rtlCol="0" anchor="ctr"/>
           <a:lstStyle/>
           <a:p>
-            <a:pPr indent="0" marL="0">
+            <a:pPr marL="0" indent="0">
               <a:buNone/>
             </a:pPr>
             <a:r>
@@ -8281,7 +8126,7 @@
           <a:bodyPr wrap="square" rtlCol="0" anchor="ctr"/>
           <a:lstStyle/>
           <a:p>
-            <a:pPr indent="0" marL="0">
+            <a:pPr marL="0" indent="0">
               <a:buNone/>
             </a:pPr>
             <a:r>
@@ -8342,7 +8187,7 @@
           <a:bodyPr wrap="square" rtlCol="0" anchor="ctr"/>
           <a:lstStyle/>
           <a:p>
-            <a:pPr indent="0" marL="0">
+            <a:pPr marL="0" indent="0">
               <a:buNone/>
             </a:pPr>
             <a:r>
@@ -8381,7 +8226,7 @@
           <a:bodyPr wrap="square" rtlCol="0" anchor="ctr"/>
           <a:lstStyle/>
           <a:p>
-            <a:pPr indent="0" marL="0">
+            <a:pPr marL="0" indent="0">
               <a:buNone/>
             </a:pPr>
             <a:r>
@@ -8420,7 +8265,7 @@
           <a:bodyPr wrap="square" rtlCol="0" anchor="ctr"/>
           <a:lstStyle/>
           <a:p>
-            <a:pPr indent="0" marL="0">
+            <a:pPr marL="0" indent="0">
               <a:buNone/>
             </a:pPr>
             <a:r>
@@ -8481,7 +8326,7 @@
           <a:bodyPr wrap="square" rtlCol="0" anchor="ctr"/>
           <a:lstStyle/>
           <a:p>
-            <a:pPr indent="0" marL="0">
+            <a:pPr marL="0" indent="0">
               <a:buNone/>
             </a:pPr>
             <a:r>
@@ -8520,7 +8365,7 @@
           <a:bodyPr wrap="square" rtlCol="0" anchor="ctr"/>
           <a:lstStyle/>
           <a:p>
-            <a:pPr indent="0" marL="0">
+            <a:pPr marL="0" indent="0">
               <a:buNone/>
             </a:pPr>
             <a:r>
@@ -8559,7 +8404,7 @@
           <a:bodyPr wrap="square" rtlCol="0" anchor="ctr"/>
           <a:lstStyle/>
           <a:p>
-            <a:pPr indent="0" marL="0">
+            <a:pPr marL="0" indent="0">
               <a:buNone/>
             </a:pPr>
             <a:r>
@@ -8620,7 +8465,7 @@
           <a:bodyPr wrap="square" rtlCol="0" anchor="ctr"/>
           <a:lstStyle/>
           <a:p>
-            <a:pPr indent="0" marL="0">
+            <a:pPr marL="0" indent="0">
               <a:buNone/>
             </a:pPr>
             <a:r>
@@ -8659,7 +8504,7 @@
           <a:bodyPr wrap="square" rtlCol="0" anchor="ctr"/>
           <a:lstStyle/>
           <a:p>
-            <a:pPr indent="0" marL="0">
+            <a:pPr marL="0" indent="0">
               <a:buNone/>
             </a:pPr>
             <a:r>
@@ -8698,7 +8543,7 @@
           <a:bodyPr wrap="square" rtlCol="0" anchor="ctr"/>
           <a:lstStyle/>
           <a:p>
-            <a:pPr indent="0" marL="0">
+            <a:pPr marL="0" indent="0">
               <a:buNone/>
             </a:pPr>
             <a:r>
@@ -8732,6 +8577,7 @@
         <a:solidFill>
           <a:srgbClr val="FAFAF7"/>
         </a:solidFill>
+        <a:effectLst/>
       </p:bgPr>
     </p:bg>
     <p:spTree>
@@ -8770,14 +8616,14 @@
       </p:sp>
       <p:pic>
         <p:nvPicPr>
-          <p:cNvPr id="3" name="Image 0" descr="preencoded.png">    </p:cNvPr>
+          <p:cNvPr id="3" name="Image 0" descr="preencoded.png"/>
           <p:cNvPicPr>
             <a:picLocks noChangeAspect="1"/>
           </p:cNvPicPr>
           <p:nvPr/>
         </p:nvPicPr>
         <p:blipFill>
-          <a:blip r:embed="rId1"/>
+          <a:blip r:embed="rId3"/>
           <a:stretch>
             <a:fillRect/>
           </a:stretch>
@@ -8813,11 +8659,11 @@
           <a:bodyPr wrap="square" rtlCol="0" anchor="ctr"/>
           <a:lstStyle/>
           <a:p>
-            <a:pPr indent="0" marL="0">
-              <a:buNone/>
-            </a:pPr>
-            <a:r>
-              <a:rPr lang="en-US" sz="1300" b="1" spc="100" kern="0" dirty="0">
+            <a:pPr marL="0" indent="0">
+              <a:buNone/>
+            </a:pPr>
+            <a:r>
+              <a:rPr lang="en-US" sz="1300" b="1" kern="0" spc="100" dirty="0">
                 <a:solidFill>
                   <a:srgbClr val="9A6B2C"/>
                 </a:solidFill>
@@ -8852,7 +8698,7 @@
           <a:bodyPr wrap="square" rtlCol="0" anchor="ctr"/>
           <a:lstStyle/>
           <a:p>
-            <a:pPr indent="0" marL="0">
+            <a:pPr marL="0" indent="0">
               <a:buNone/>
             </a:pPr>
             <a:r>
@@ -8913,7 +8759,7 @@
           <a:bodyPr wrap="square" rtlCol="0" anchor="ctr"/>
           <a:lstStyle/>
           <a:p>
-            <a:pPr indent="0" marL="0">
+            <a:pPr marL="0" indent="0">
               <a:buNone/>
             </a:pPr>
             <a:r>
@@ -8952,7 +8798,7 @@
           <a:bodyPr wrap="square" rtlCol="0" anchor="ctr"/>
           <a:lstStyle/>
           <a:p>
-            <a:pPr indent="0" marL="0">
+            <a:pPr marL="0" indent="0">
               <a:buNone/>
             </a:pPr>
             <a:r>
@@ -8991,7 +8837,7 @@
           <a:bodyPr wrap="square" rtlCol="0" anchor="ctr"/>
           <a:lstStyle/>
           <a:p>
-            <a:pPr indent="0" marL="0">
+            <a:pPr marL="0" indent="0">
               <a:buNone/>
             </a:pPr>
             <a:r>
@@ -9150,7 +8996,7 @@
           <a:bodyPr wrap="square" rtlCol="0" anchor="ctr"/>
           <a:lstStyle/>
           <a:p>
-            <a:pPr indent="0" marL="0">
+            <a:pPr marL="0" indent="0">
               <a:buNone/>
             </a:pPr>
             <a:r>
@@ -9184,6 +9030,7 @@
         <a:solidFill>
           <a:srgbClr val="FAFAF7"/>
         </a:solidFill>
+        <a:effectLst/>
       </p:bgPr>
     </p:bg>
     <p:spTree>
@@ -9222,14 +9069,14 @@
       </p:sp>
       <p:pic>
         <p:nvPicPr>
-          <p:cNvPr id="3" name="Image 0" descr="preencoded.png">    </p:cNvPr>
+          <p:cNvPr id="3" name="Image 0" descr="preencoded.png"/>
           <p:cNvPicPr>
             <a:picLocks noChangeAspect="1"/>
           </p:cNvPicPr>
           <p:nvPr/>
         </p:nvPicPr>
         <p:blipFill>
-          <a:blip r:embed="rId1"/>
+          <a:blip r:embed="rId3"/>
           <a:stretch>
             <a:fillRect/>
           </a:stretch>
@@ -9265,11 +9112,11 @@
           <a:bodyPr wrap="square" rtlCol="0" anchor="ctr"/>
           <a:lstStyle/>
           <a:p>
-            <a:pPr indent="0" marL="0">
-              <a:buNone/>
-            </a:pPr>
-            <a:r>
-              <a:rPr lang="en-US" sz="1300" b="1" spc="100" kern="0" dirty="0">
+            <a:pPr marL="0" indent="0">
+              <a:buNone/>
+            </a:pPr>
+            <a:r>
+              <a:rPr lang="en-US" sz="1300" b="1" kern="0" spc="100" dirty="0">
                 <a:solidFill>
                   <a:srgbClr val="9A6B2C"/>
                 </a:solidFill>
@@ -9304,7 +9151,7 @@
           <a:bodyPr wrap="square" rtlCol="0" anchor="ctr"/>
           <a:lstStyle/>
           <a:p>
-            <a:pPr indent="0" marL="0">
+            <a:pPr marL="0" indent="0">
               <a:buNone/>
             </a:pPr>
             <a:r>
@@ -9343,7 +9190,7 @@
           </a:solidFill>
           <a:ln/>
           <a:effectLst>
-            <a:outerShdw sx="100000" sy="100000" kx="0" ky="0" algn="bl" rotWithShape="0" blurRad="76200" dist="25400" dir="5400000">
+            <a:outerShdw blurRad="76200" dist="25400" dir="5400000" algn="bl" rotWithShape="0">
               <a:srgbClr val="000000">
                 <a:alpha val="8000"/>
               </a:srgbClr>
@@ -9372,7 +9219,7 @@
           <a:bodyPr wrap="square" rtlCol="0" anchor="ctr"/>
           <a:lstStyle/>
           <a:p>
-            <a:pPr indent="0" marL="0">
+            <a:pPr marL="0" indent="0">
               <a:buNone/>
             </a:pPr>
             <a:r>
@@ -9411,7 +9258,7 @@
           <a:bodyPr wrap="square" rtlCol="0" anchor="ctr"/>
           <a:lstStyle/>
           <a:p>
-            <a:pPr indent="0" marL="0">
+            <a:pPr marL="0" indent="0">
               <a:lnSpc>
                 <a:spcPct val="125000"/>
               </a:lnSpc>
@@ -9431,7 +9278,7 @@
             <a:endParaRPr lang="en-US" sz="1300" dirty="0"/>
           </a:p>
           <a:p>
-            <a:pPr indent="0" marL="0">
+            <a:pPr marL="0" indent="0">
               <a:lnSpc>
                 <a:spcPct val="125000"/>
               </a:lnSpc>
@@ -9440,7 +9287,7 @@
             <a:endParaRPr lang="en-US" sz="1300" dirty="0"/>
           </a:p>
           <a:p>
-            <a:pPr indent="0" marL="0">
+            <a:pPr marL="0" indent="0">
               <a:lnSpc>
                 <a:spcPct val="125000"/>
               </a:lnSpc>
@@ -9504,7 +9351,7 @@
           <a:bodyPr wrap="square" rtlCol="0" anchor="ctr"/>
           <a:lstStyle/>
           <a:p>
-            <a:pPr indent="0" marL="0">
+            <a:pPr marL="0" indent="0">
               <a:buNone/>
             </a:pPr>
             <a:r>
@@ -9983,4 +9830,299 @@
     </a:ext>
   </a:extLst>
 </a:theme>
+</file>
+
+<file path=ppt/theme/theme2.xml><?xml version="1.0" encoding="utf-8"?>
+<a:theme xmlns:a="http://schemas.openxmlformats.org/drawingml/2006/main" name="Office Theme">
+  <a:themeElements>
+    <a:clrScheme name="Office">
+      <a:dk1>
+        <a:sysClr val="windowText" lastClr="000000"/>
+      </a:dk1>
+      <a:lt1>
+        <a:sysClr val="window" lastClr="FFFFFF"/>
+      </a:lt1>
+      <a:dk2>
+        <a:srgbClr val="44546A"/>
+      </a:dk2>
+      <a:lt2>
+        <a:srgbClr val="E7E6E6"/>
+      </a:lt2>
+      <a:accent1>
+        <a:srgbClr val="4472C4"/>
+      </a:accent1>
+      <a:accent2>
+        <a:srgbClr val="ED7D31"/>
+      </a:accent2>
+      <a:accent3>
+        <a:srgbClr val="A5A5A5"/>
+      </a:accent3>
+      <a:accent4>
+        <a:srgbClr val="FFC000"/>
+      </a:accent4>
+      <a:accent5>
+        <a:srgbClr val="5B9BD5"/>
+      </a:accent5>
+      <a:accent6>
+        <a:srgbClr val="70AD47"/>
+      </a:accent6>
+      <a:hlink>
+        <a:srgbClr val="0563C1"/>
+      </a:hlink>
+      <a:folHlink>
+        <a:srgbClr val="954F72"/>
+      </a:folHlink>
+    </a:clrScheme>
+    <a:fontScheme name="Office">
+      <a:majorFont>
+        <a:latin typeface="Calibri Light" panose="020F0302020204030204"/>
+        <a:ea typeface=""/>
+        <a:cs typeface=""/>
+        <a:font script="Jpan" typeface="游ゴシック Light"/>
+        <a:font script="Hang" typeface="맑은 고딕"/>
+        <a:font script="Hans" typeface="等线 Light"/>
+        <a:font script="Hant" typeface="新細明體"/>
+        <a:font script="Arab" typeface="Times New Roman"/>
+        <a:font script="Hebr" typeface="Times New Roman"/>
+        <a:font script="Thai" typeface="Angsana New"/>
+        <a:font script="Ethi" typeface="Nyala"/>
+        <a:font script="Beng" typeface="Vrinda"/>
+        <a:font script="Gujr" typeface="Shruti"/>
+        <a:font script="Khmr" typeface="MoolBoran"/>
+        <a:font script="Knda" typeface="Tunga"/>
+        <a:font script="Guru" typeface="Raavi"/>
+        <a:font script="Cans" typeface="Euphemia"/>
+        <a:font script="Cher" typeface="Plantagenet Cherokee"/>
+        <a:font script="Yiii" typeface="Microsoft Yi Baiti"/>
+        <a:font script="Tibt" typeface="Microsoft Himalaya"/>
+        <a:font script="Thaa" typeface="MV Boli"/>
+        <a:font script="Deva" typeface="Mangal"/>
+        <a:font script="Telu" typeface="Gautami"/>
+        <a:font script="Taml" typeface="Latha"/>
+        <a:font script="Syrc" typeface="Estrangelo Edessa"/>
+        <a:font script="Orya" typeface="Kalinga"/>
+        <a:font script="Mlym" typeface="Kartika"/>
+        <a:font script="Laoo" typeface="DokChampa"/>
+        <a:font script="Sinh" typeface="Iskoola Pota"/>
+        <a:font script="Mong" typeface="Mongolian Baiti"/>
+        <a:font script="Viet" typeface="Times New Roman"/>
+        <a:font script="Uigh" typeface="Microsoft Uighur"/>
+        <a:font script="Geor" typeface="Sylfaen"/>
+        <a:font script="Armn" typeface="Arial"/>
+        <a:font script="Bugi" typeface="Leelawadee UI"/>
+        <a:font script="Bopo" typeface="Microsoft JhengHei"/>
+        <a:font script="Java" typeface="Javanese Text"/>
+        <a:font script="Lisu" typeface="Segoe UI"/>
+        <a:font script="Mymr" typeface="Myanmar Text"/>
+        <a:font script="Nkoo" typeface="Ebrima"/>
+        <a:font script="Olck" typeface="Nirmala UI"/>
+        <a:font script="Osma" typeface="Ebrima"/>
+        <a:font script="Phag" typeface="Phagspa"/>
+        <a:font script="Syrn" typeface="Estrangelo Edessa"/>
+        <a:font script="Syrj" typeface="Estrangelo Edessa"/>
+        <a:font script="Syre" typeface="Estrangelo Edessa"/>
+        <a:font script="Sora" typeface="Nirmala UI"/>
+        <a:font script="Tale" typeface="Microsoft Tai Le"/>
+        <a:font script="Talu" typeface="Microsoft New Tai Lue"/>
+        <a:font script="Tfng" typeface="Ebrima"/>
+      </a:majorFont>
+      <a:minorFont>
+        <a:latin typeface="Calibri" panose="020F0502020204030204"/>
+        <a:ea typeface=""/>
+        <a:cs typeface=""/>
+        <a:font script="Jpan" typeface="游ゴシック"/>
+        <a:font script="Hang" typeface="맑은 고딕"/>
+        <a:font script="Hans" typeface="等线"/>
+        <a:font script="Hant" typeface="新細明體"/>
+        <a:font script="Arab" typeface="Arial"/>
+        <a:font script="Hebr" typeface="Arial"/>
+        <a:font script="Thai" typeface="Cordia New"/>
+        <a:font script="Ethi" typeface="Nyala"/>
+        <a:font script="Beng" typeface="Vrinda"/>
+        <a:font script="Gujr" typeface="Shruti"/>
+        <a:font script="Khmr" typeface="DaunPenh"/>
+        <a:font script="Knda" typeface="Tunga"/>
+        <a:font script="Guru" typeface="Raavi"/>
+        <a:font script="Cans" typeface="Euphemia"/>
+        <a:font script="Cher" typeface="Plantagenet Cherokee"/>
+        <a:font script="Yiii" typeface="Microsoft Yi Baiti"/>
+        <a:font script="Tibt" typeface="Microsoft Himalaya"/>
+        <a:font script="Thaa" typeface="MV Boli"/>
+        <a:font script="Deva" typeface="Mangal"/>
+        <a:font script="Telu" typeface="Gautami"/>
+        <a:font script="Taml" typeface="Latha"/>
+        <a:font script="Syrc" typeface="Estrangelo Edessa"/>
+        <a:font script="Orya" typeface="Kalinga"/>
+        <a:font script="Mlym" typeface="Kartika"/>
+        <a:font script="Laoo" typeface="DokChampa"/>
+        <a:font script="Sinh" typeface="Iskoola Pota"/>
+        <a:font script="Mong" typeface="Mongolian Baiti"/>
+        <a:font script="Viet" typeface="Arial"/>
+        <a:font script="Uigh" typeface="Microsoft Uighur"/>
+        <a:font script="Geor" typeface="Sylfaen"/>
+        <a:font script="Armn" typeface="Arial"/>
+        <a:font script="Bugi" typeface="Leelawadee UI"/>
+        <a:font script="Bopo" typeface="Microsoft JhengHei"/>
+        <a:font script="Java" typeface="Javanese Text"/>
+        <a:font script="Lisu" typeface="Segoe UI"/>
+        <a:font script="Mymr" typeface="Myanmar Text"/>
+        <a:font script="Nkoo" typeface="Ebrima"/>
+        <a:font script="Olck" typeface="Nirmala UI"/>
+        <a:font script="Osma" typeface="Ebrima"/>
+        <a:font script="Phag" typeface="Phagspa"/>
+        <a:font script="Syrn" typeface="Estrangelo Edessa"/>
+        <a:font script="Syrj" typeface="Estrangelo Edessa"/>
+        <a:font script="Syre" typeface="Estrangelo Edessa"/>
+        <a:font script="Sora" typeface="Nirmala UI"/>
+        <a:font script="Tale" typeface="Microsoft Tai Le"/>
+        <a:font script="Talu" typeface="Microsoft New Tai Lue"/>
+        <a:font script="Tfng" typeface="Ebrima"/>
+      </a:minorFont>
+    </a:fontScheme>
+    <a:fmtScheme name="Office">
+      <a:fillStyleLst>
+        <a:solidFill>
+          <a:schemeClr val="phClr"/>
+        </a:solidFill>
+        <a:gradFill rotWithShape="1">
+          <a:gsLst>
+            <a:gs pos="0">
+              <a:schemeClr val="phClr">
+                <a:lumMod val="110000"/>
+                <a:satMod val="105000"/>
+                <a:tint val="67000"/>
+              </a:schemeClr>
+            </a:gs>
+            <a:gs pos="50000">
+              <a:schemeClr val="phClr">
+                <a:lumMod val="105000"/>
+                <a:satMod val="103000"/>
+                <a:tint val="73000"/>
+              </a:schemeClr>
+            </a:gs>
+            <a:gs pos="100000">
+              <a:schemeClr val="phClr">
+                <a:lumMod val="105000"/>
+                <a:satMod val="109000"/>
+                <a:tint val="81000"/>
+              </a:schemeClr>
+            </a:gs>
+          </a:gsLst>
+          <a:lin ang="5400000" scaled="0"/>
+        </a:gradFill>
+        <a:gradFill rotWithShape="1">
+          <a:gsLst>
+            <a:gs pos="0">
+              <a:schemeClr val="phClr">
+                <a:satMod val="103000"/>
+                <a:lumMod val="102000"/>
+                <a:tint val="94000"/>
+              </a:schemeClr>
+            </a:gs>
+            <a:gs pos="50000">
+              <a:schemeClr val="phClr">
+                <a:satMod val="110000"/>
+                <a:lumMod val="100000"/>
+                <a:shade val="100000"/>
+              </a:schemeClr>
+            </a:gs>
+            <a:gs pos="100000">
+              <a:schemeClr val="phClr">
+                <a:lumMod val="99000"/>
+                <a:satMod val="120000"/>
+                <a:shade val="78000"/>
+              </a:schemeClr>
+            </a:gs>
+          </a:gsLst>
+          <a:lin ang="5400000" scaled="0"/>
+        </a:gradFill>
+      </a:fillStyleLst>
+      <a:lnStyleLst>
+        <a:ln w="6350" cap="flat" cmpd="sng" algn="ctr">
+          <a:solidFill>
+            <a:schemeClr val="phClr"/>
+          </a:solidFill>
+          <a:prstDash val="solid"/>
+          <a:miter lim="800000"/>
+        </a:ln>
+        <a:ln w="12700" cap="flat" cmpd="sng" algn="ctr">
+          <a:solidFill>
+            <a:schemeClr val="phClr"/>
+          </a:solidFill>
+          <a:prstDash val="solid"/>
+          <a:miter lim="800000"/>
+        </a:ln>
+        <a:ln w="19050" cap="flat" cmpd="sng" algn="ctr">
+          <a:solidFill>
+            <a:schemeClr val="phClr"/>
+          </a:solidFill>
+          <a:prstDash val="solid"/>
+          <a:miter lim="800000"/>
+        </a:ln>
+      </a:lnStyleLst>
+      <a:effectStyleLst>
+        <a:effectStyle>
+          <a:effectLst/>
+        </a:effectStyle>
+        <a:effectStyle>
+          <a:effectLst/>
+        </a:effectStyle>
+        <a:effectStyle>
+          <a:effectLst>
+            <a:outerShdw blurRad="57150" dist="19050" dir="5400000" algn="ctr" rotWithShape="0">
+              <a:srgbClr val="000000">
+                <a:alpha val="63000"/>
+              </a:srgbClr>
+            </a:outerShdw>
+          </a:effectLst>
+        </a:effectStyle>
+      </a:effectStyleLst>
+      <a:bgFillStyleLst>
+        <a:solidFill>
+          <a:schemeClr val="phClr"/>
+        </a:solidFill>
+        <a:solidFill>
+          <a:schemeClr val="phClr">
+            <a:tint val="95000"/>
+            <a:satMod val="170000"/>
+          </a:schemeClr>
+        </a:solidFill>
+        <a:gradFill rotWithShape="1">
+          <a:gsLst>
+            <a:gs pos="0">
+              <a:schemeClr val="phClr">
+                <a:tint val="93000"/>
+                <a:satMod val="150000"/>
+                <a:shade val="98000"/>
+                <a:lumMod val="102000"/>
+              </a:schemeClr>
+            </a:gs>
+            <a:gs pos="50000">
+              <a:schemeClr val="phClr">
+                <a:tint val="98000"/>
+                <a:satMod val="130000"/>
+                <a:shade val="90000"/>
+                <a:lumMod val="103000"/>
+              </a:schemeClr>
+            </a:gs>
+            <a:gs pos="100000">
+              <a:schemeClr val="phClr">
+                <a:shade val="63000"/>
+                <a:satMod val="120000"/>
+              </a:schemeClr>
+            </a:gs>
+          </a:gsLst>
+          <a:lin ang="5400000" scaled="0"/>
+        </a:gradFill>
+      </a:bgFillStyleLst>
+    </a:fmtScheme>
+  </a:themeElements>
+  <a:objectDefaults/>
+  <a:extraClrSchemeLst/>
+  <a:extLst>
+    <a:ext uri="{05A4C25C-085E-4340-85A3-A5531E510DB2}">
+      <thm15:themeFamily xmlns:thm15="http://schemas.microsoft.com/office/thememl/2012/main" name="Office Theme" id="{62F939B6-93AF-4DB8-9C6B-D6C7DFDC589F}" vid="{4A3C46E8-61CC-4603-A589-7422A47A8E4A}"/>
+    </a:ext>
+  </a:extLst>
+</a:theme>
 </file>
</xml_diff>